<commit_message>
Update the deck for rule-only refutation and the retrospective benchmark
Brings both deck files in line with PR #43, which the deck predates.

Slide 3: the Refute box loses its "optional LLM" badge and styling and
now reads "rules over facts"; the legend says the model assists one
edge (parse); the caption says every caveat is derived by rules, so no
model sentence enters a report.

Slide 6: the "no fabrication" callout no longer describes the removed
model-observations layer and its numeric guard; it states the stage is
rule-only and why the guard was dropped rather than patched.

Slides 2 and 10: the Hubbard & Schlom comparison is called a
retrospective benchmark, not held out, matching the eval check title.

Co-Authored-By: Claude Opus 5 <noreply@anthropic.com>
</commit_message>
<xml_diff>
--- a/docs/presentation/Oxbow.pptx
+++ b/docs/presentation/Oxbow.pptx
@@ -2909,7 +2909,7 @@
                 <a:ea typeface="Calibri" pitchFamily="34" charset="-122"/>
                 <a:cs typeface="Calibri" pitchFamily="34" charset="-120"/>
               </a:rPr>
-              <a:t>Interface vs Hubbard &amp; Schlom, 21/21</a:t>
+              <a:t>Retrospective benchmark vs Hubbard &amp; Schlom, 21/21</a:t>
             </a:r>
             <a:endParaRPr lang="en-US" sz="1200" dirty="0"/>
           </a:p>
@@ -5565,7 +5565,7 @@
                 <a:ea typeface="Calibri" pitchFamily="34" charset="-122"/>
                 <a:cs typeface="Calibri" pitchFamily="34" charset="-120"/>
               </a:rPr>
-              <a:t>Held out against Hubbard &amp; Schlom (1996) for the interface criterion: 21 / 21 hard assertions.</a:t>
+              <a:t>Retrospective benchmark against Hubbard &amp; Schlom (1996) for the interface criterion: 21 / 21 hard assertions.</a:t>
             </a:r>
             <a:endParaRPr lang="en-US" sz="1250" dirty="0"/>
           </a:p>
@@ -6031,11 +6031,11 @@
             </a:avLst>
           </a:prstGeom>
           <a:solidFill>
-            <a:srgbClr val="EAF6FB"/>
+            <a:srgbClr val="FFFFFF"/>
           </a:solidFill>
           <a:ln w="12700">
             <a:solidFill>
-              <a:srgbClr val="9CC8DE"/>
+              <a:srgbClr val="D8E2E9"/>
             </a:solidFill>
             <a:prstDash val="solid"/>
           </a:ln>
@@ -6043,14 +6043,14 @@
       </p:sp>
       <p:sp>
         <p:nvSpPr>
-          <p:cNvPr id="12" name="Text 10"/>
-          <p:cNvSpPr txBox="1"/>
-          <p:nvPr/>
-        </p:nvSpPr>
-        <p:spPr>
-          <a:xfrm>
-            <a:off x="9656064" y="2258568"/>
-            <a:ext cx="1965960" cy="201168"/>
+          <p:cNvPr id="13" name="Text 11"/>
+          <p:cNvSpPr txBox="1"/>
+          <p:nvPr/>
+        </p:nvSpPr>
+        <p:spPr>
+          <a:xfrm>
+            <a:off x="9656064" y="2368296"/>
+            <a:ext cx="1965960" cy="310896"/>
           </a:xfrm>
           <a:prstGeom prst="rect">
             <a:avLst/>
@@ -6066,93 +6066,54 @@
               <a:buNone/>
             </a:pPr>
             <a:r>
-              <a:rPr lang="en-US" sz="850" b="1" dirty="0">
-                <a:solidFill>
-                  <a:srgbClr val="2A6F97"/>
+              <a:rPr lang="en-US" sz="1400" b="1" dirty="0">
+                <a:solidFill>
+                  <a:srgbClr val="14213D"/>
+                </a:solidFill>
+                <a:latin typeface="Calibri" pitchFamily="34" charset="0"/>
+                <a:ea typeface="Calibri" pitchFamily="34" charset="-122"/>
+                <a:cs typeface="Calibri" pitchFamily="34" charset="-120"/>
+              </a:rPr>
+              <a:t>Refute</a:t>
+            </a:r>
+            <a:endParaRPr lang="en-US" sz="1400" dirty="0"/>
+          </a:p>
+        </p:txBody>
+      </p:sp>
+      <p:sp>
+        <p:nvSpPr>
+          <p:cNvPr id="14" name="Text 12"/>
+          <p:cNvSpPr txBox="1"/>
+          <p:nvPr/>
+        </p:nvSpPr>
+        <p:spPr>
+          <a:xfrm>
+            <a:off x="9656064" y="2715768"/>
+            <a:ext cx="1965960" cy="274320"/>
+          </a:xfrm>
+          <a:prstGeom prst="rect">
+            <a:avLst/>
+          </a:prstGeom>
+          <a:noFill/>
+          <a:ln/>
+        </p:spPr>
+        <p:txBody>
+          <a:bodyPr wrap="square" lIns="0" tIns="0" rIns="0" bIns="0" rtlCol="0" anchor="ctr"/>
+          <a:lstStyle/>
+          <a:p>
+            <a:pPr algn="ctr" indent="0" marL="0">
+              <a:buNone/>
+            </a:pPr>
+            <a:r>
+              <a:rPr lang="en-US" sz="850" dirty="0">
+                <a:solidFill>
+                  <a:srgbClr val="64748B"/>
                 </a:solidFill>
                 <a:latin typeface="Courier New" pitchFamily="34" charset="0"/>
                 <a:ea typeface="Courier New" pitchFamily="34" charset="-122"/>
                 <a:cs typeface="Courier New" pitchFamily="34" charset="-120"/>
               </a:rPr>
-              <a:t>◐ OPTIONAL LLM</a:t>
-            </a:r>
-            <a:endParaRPr lang="en-US" sz="850" dirty="0"/>
-          </a:p>
-        </p:txBody>
-      </p:sp>
-      <p:sp>
-        <p:nvSpPr>
-          <p:cNvPr id="13" name="Text 11"/>
-          <p:cNvSpPr txBox="1"/>
-          <p:nvPr/>
-        </p:nvSpPr>
-        <p:spPr>
-          <a:xfrm>
-            <a:off x="9656064" y="2459736"/>
-            <a:ext cx="1965960" cy="310896"/>
-          </a:xfrm>
-          <a:prstGeom prst="rect">
-            <a:avLst/>
-          </a:prstGeom>
-          <a:noFill/>
-          <a:ln/>
-        </p:spPr>
-        <p:txBody>
-          <a:bodyPr wrap="square" lIns="0" tIns="0" rIns="0" bIns="0" rtlCol="0" anchor="ctr"/>
-          <a:lstStyle/>
-          <a:p>
-            <a:pPr algn="ctr" indent="0" marL="0">
-              <a:buNone/>
-            </a:pPr>
-            <a:r>
-              <a:rPr lang="en-US" sz="1400" b="1" dirty="0">
-                <a:solidFill>
-                  <a:srgbClr val="14213D"/>
-                </a:solidFill>
-                <a:latin typeface="Calibri" pitchFamily="34" charset="0"/>
-                <a:ea typeface="Calibri" pitchFamily="34" charset="-122"/>
-                <a:cs typeface="Calibri" pitchFamily="34" charset="-120"/>
-              </a:rPr>
-              <a:t>Refute</a:t>
-            </a:r>
-            <a:endParaRPr lang="en-US" sz="1400" dirty="0"/>
-          </a:p>
-        </p:txBody>
-      </p:sp>
-      <p:sp>
-        <p:nvSpPr>
-          <p:cNvPr id="14" name="Text 12"/>
-          <p:cNvSpPr txBox="1"/>
-          <p:nvPr/>
-        </p:nvSpPr>
-        <p:spPr>
-          <a:xfrm>
-            <a:off x="9656064" y="2770632"/>
-            <a:ext cx="1965960" cy="274320"/>
-          </a:xfrm>
-          <a:prstGeom prst="rect">
-            <a:avLst/>
-          </a:prstGeom>
-          <a:noFill/>
-          <a:ln/>
-        </p:spPr>
-        <p:txBody>
-          <a:bodyPr wrap="square" lIns="0" tIns="0" rIns="0" bIns="0" rtlCol="0" anchor="ctr"/>
-          <a:lstStyle/>
-          <a:p>
-            <a:pPr algn="ctr" indent="0" marL="0">
-              <a:buNone/>
-            </a:pPr>
-            <a:r>
-              <a:rPr lang="en-US" sz="850" dirty="0">
-                <a:solidFill>
-                  <a:srgbClr val="64748B"/>
-                </a:solidFill>
-                <a:latin typeface="Courier New" pitchFamily="34" charset="0"/>
-                <a:ea typeface="Courier New" pitchFamily="34" charset="-122"/>
-                <a:cs typeface="Courier New" pitchFamily="34" charset="-120"/>
-              </a:rPr>
-              <a:t>argues over facts</a:t>
+              <a:t>rules over facts</a:t>
             </a:r>
             <a:endParaRPr lang="en-US" sz="850" dirty="0"/>
           </a:p>
@@ -6868,7 +6829,7 @@
                 <a:ea typeface="Calibri" pitchFamily="34" charset="-122"/>
                 <a:cs typeface="Calibri" pitchFamily="34" charset="-120"/>
               </a:rPr>
-              <a:t>The model interprets the request, phrases an answer, and can add caveats. The LLM is structurally blocked from changing a number, rank, or citation.</a:t>
+              <a:t>The model interprets the request and fills fields the rules left at default. Every caveat is derived by rules from structured facts, so no model sentence enters a report. The LLM is structurally blocked from changing a number, rank, citation, or caveat.</a:t>
             </a:r>
             <a:endParaRPr lang="en-US" sz="1350" dirty="0"/>
           </a:p>
@@ -11121,7 +11082,7 @@
                 <a:ea typeface="Calibri" pitchFamily="34" charset="-122"/>
                 <a:cs typeface="Calibri" pitchFamily="34" charset="-120"/>
               </a:rPr>
-              <a:t>The refutation stage lets the model add at most three observations per candidate — but each must cite an existing fact, and a numeric guard discards any number or citation not already in the data. The model can add words; it cannot add claims.</a:t>
+              <a:t>The refutation stage is rule-only: every caveat is derived from structured facts, so no model sentence enters a report. An earlier version let the model add observations behind a numeric guard; a guard that checks numbers as a bag cannot tell a band gap from a dielectric constant, so the layer was removed.</a:t>
             </a:r>
             <a:endParaRPr lang="en-US" sz="1300" dirty="0"/>
           </a:p>

</xml_diff>

<commit_message>
Add a ranking-criteria and hard-gates slide after Architecture
New slide 4, "Gates set the floor; criteria order the rest", in both the
HTML deck and the PPTX. Left: a table of the seven weighted criteria with
their default weights and the rule that maps each to 0-1, the figure of
merit marked as the profile-owned one. Right: the four always-on hard
gates, the request-level element gates, and a note that interface and
literature only score, which is why Ta2O5 ranks 99th rather than vanishing.

Values are read from config/default.yaml and scoring/core.py. The deck
README now says 13 slides.

Co-Authored-By: Claude Opus 5 <noreply@anthropic.com>
</commit_message>
<xml_diff>
--- a/docs/presentation/Oxbow.pptx
+++ b/docs/presentation/Oxbow.pptx
@@ -8,6 +8,7 @@
     <p:sldId id="256" r:id="rId2"/>
     <p:sldId id="257" r:id="rId3"/>
     <p:sldId id="258" r:id="rId4"/>
+    <p:sldId id="268" r:id="rId19"/>
     <p:sldId id="259" r:id="rId5"/>
     <p:sldId id="260" r:id="rId6"/>
     <p:sldId id="261" r:id="rId7"/>
@@ -5086,6 +5087,2225 @@
 </p:sld>
 </file>
 
+<file path=ppt/slides/slide13.xml><?xml version="1.0" encoding="utf-8"?>
+<p:sld xmlns:a="http://schemas.openxmlformats.org/drawingml/2006/main" xmlns:r="http://schemas.openxmlformats.org/officeDocument/2006/relationships" xmlns:p="http://schemas.openxmlformats.org/presentationml/2006/main">
+  <p:cSld name="Slide 13">
+    <p:bg>
+      <p:bgPr>
+        <a:solidFill>
+          <a:srgbClr val="FFFFFF"/>
+        </a:solidFill>
+      </p:bgPr>
+    </p:bg>
+    <p:spTree>
+      <p:nvGrpSpPr>
+        <p:cNvPr id="1" name=""/>
+        <p:cNvGrpSpPr/>
+        <p:nvPr/>
+      </p:nvGrpSpPr>
+      <p:grpSpPr>
+        <a:xfrm>
+          <a:off x="0" y="0"/>
+          <a:ext cx="0" cy="0"/>
+          <a:chOff x="0" y="0"/>
+          <a:chExt cx="0" cy="0"/>
+        </a:xfrm>
+      </p:grpSpPr>
+      <p:sp>
+        <p:nvSpPr>
+          <p:cNvPr id="2" name="Text 2"/>
+          <p:cNvSpPr txBox="1"/>
+          <p:nvPr/>
+        </p:nvSpPr>
+        <p:spPr>
+          <a:xfrm>
+            <a:off x="566928" y="457200"/>
+            <a:ext cx="11055096" cy="292608"/>
+          </a:xfrm>
+          <a:prstGeom prst="rect">
+            <a:avLst/>
+          </a:prstGeom>
+          <a:noFill/>
+          <a:ln/>
+        </p:spPr>
+        <p:txBody>
+          <a:bodyPr wrap="square" lIns="0" tIns="0" rIns="0" bIns="0" rtlCol="0" anchor="ctr"/>
+          <a:lstStyle/>
+          <a:p>
+            <a:pPr algn="l" indent="0" marL="0">
+              <a:buNone/>
+            </a:pPr>
+            <a:r>
+              <a:rPr lang="en-US" sz="1150" b="1" spc="200" dirty="0">
+                <a:solidFill>
+                  <a:srgbClr val="2A6F97"/>
+                </a:solidFill>
+                <a:latin typeface="Courier New" pitchFamily="34" charset="0"/>
+                <a:ea typeface="Courier New" pitchFamily="34" charset="-122"/>
+                <a:cs typeface="Courier New" pitchFamily="34" charset="-120"/>
+              </a:rPr>
+              <a:t>HOW IT RANKS</a:t>
+            </a:r>
+          </a:p>
+        </p:txBody>
+      </p:sp>
+      <p:sp>
+        <p:nvSpPr>
+          <p:cNvPr id="3" name="Text 3"/>
+          <p:cNvSpPr txBox="1"/>
+          <p:nvPr/>
+        </p:nvSpPr>
+        <p:spPr>
+          <a:xfrm>
+            <a:off x="566928" y="804672"/>
+            <a:ext cx="11055096" cy="822960"/>
+          </a:xfrm>
+          <a:prstGeom prst="rect">
+            <a:avLst/>
+          </a:prstGeom>
+          <a:noFill/>
+          <a:ln/>
+        </p:spPr>
+        <p:txBody>
+          <a:bodyPr wrap="square" lIns="0" tIns="0" rIns="0" bIns="0" rtlCol="0" anchor="ctr"/>
+          <a:lstStyle/>
+          <a:p>
+            <a:pPr algn="l" indent="0" marL="0">
+              <a:lnSpc>
+                <a:spcPts val="3366"/>
+              </a:lnSpc>
+              <a:buNone/>
+            </a:pPr>
+            <a:r>
+              <a:rPr lang="en-US" sz="3300" b="1" dirty="0">
+                <a:solidFill>
+                  <a:srgbClr val="14213D"/>
+                </a:solidFill>
+                <a:latin typeface="Calibri" pitchFamily="34" charset="0"/>
+                <a:ea typeface="Calibri" pitchFamily="34" charset="-122"/>
+                <a:cs typeface="Calibri" pitchFamily="34" charset="-120"/>
+              </a:rPr>
+              <a:t>Gates set the floor; criteria order the rest.</a:t>
+            </a:r>
+          </a:p>
+        </p:txBody>
+      </p:sp>
+      <p:sp>
+        <p:nvSpPr>
+          <p:cNvPr id="4" name="Text 4"/>
+          <p:cNvSpPr txBox="1"/>
+          <p:nvPr/>
+        </p:nvSpPr>
+        <p:spPr>
+          <a:xfrm>
+            <a:off x="566928" y="1664208"/>
+            <a:ext cx="11055096" cy="329184"/>
+          </a:xfrm>
+          <a:prstGeom prst="rect">
+            <a:avLst/>
+          </a:prstGeom>
+          <a:noFill/>
+          <a:ln/>
+        </p:spPr>
+        <p:txBody>
+          <a:bodyPr wrap="square" lIns="0" tIns="0" rIns="0" bIns="0" rtlCol="0" anchor="ctr"/>
+          <a:lstStyle/>
+          <a:p>
+            <a:pPr algn="l" indent="0" marL="0">
+              <a:buNone/>
+            </a:pPr>
+            <a:r>
+              <a:rPr lang="en-US" sz="1250" dirty="0">
+                <a:solidFill>
+                  <a:srgbClr val="64748B"/>
+                </a:solidFill>
+                <a:latin typeface="Calibri" pitchFamily="34" charset="0"/>
+                <a:ea typeface="Calibri" pitchFamily="34" charset="-122"/>
+                <a:cs typeface="Calibri" pitchFamily="34" charset="-120"/>
+              </a:rPr>
+              <a:t>Four gates exclude before scoring, each with a stated reason. Six criteria are generic; the seventh is what the profile ranks for.</a:t>
+            </a:r>
+          </a:p>
+        </p:txBody>
+      </p:sp>
+      <p:graphicFrame>
+        <p:nvGraphicFramePr>
+          <p:cNvPr id="5" name="Table 5"/>
+          <p:cNvGraphicFramePr>
+            <a:graphicFrameLocks noGrp="1"/>
+          </p:cNvGraphicFramePr>
+          <p:nvPr/>
+        </p:nvGraphicFramePr>
+        <p:xfrm>
+          <a:off x="566928" y="2148840"/>
+          <a:ext cx="6720840" cy="2889504"/>
+        </p:xfrm>
+        <a:graphic>
+          <a:graphicData uri="http://schemas.openxmlformats.org/drawingml/2006/table">
+            <a:tbl>
+              <a:tblPr/>
+              <a:tblGrid>
+                <a:gridCol w="1600200"/>
+                <a:gridCol w="777240"/>
+                <a:gridCol w="4343400"/>
+              </a:tblGrid>
+              <a:tr h="329184">
+                <a:tc>
+                  <a:txBody>
+                    <a:bodyPr/>
+                    <a:lstStyle/>
+                    <a:p>
+                      <a:pPr algn="l" indent="0" marL="0">
+                        <a:buNone/>
+                      </a:pPr>
+                      <a:r>
+                        <a:rPr lang="en-US" sz="1000" b="1" dirty="0">
+                          <a:solidFill>
+                            <a:srgbClr val="64748B"/>
+                          </a:solidFill>
+                          <a:latin typeface="Courier New" pitchFamily="34" charset="0"/>
+                          <a:ea typeface="Courier New" pitchFamily="34" charset="-122"/>
+                          <a:cs typeface="Courier New" pitchFamily="34" charset="-120"/>
+                        </a:rPr>
+                        <a:t>CRITERION</a:t>
+                      </a:r>
+                    </a:p>
+                  </a:txBody>
+                  <a:tcPr marL="76200" marR="76200" marT="25400" marB="25400" anchor="ctr">
+                    <a:lnL w="6350" cap="flat" cmpd="sng" algn="ctr">
+                      <a:solidFill>
+                        <a:srgbClr val="E7EEF2"/>
+                      </a:solidFill>
+                      <a:prstDash val="solid"/>
+                      <a:round/>
+                      <a:headEnd type="none" w="med" len="med"/>
+                      <a:tailEnd type="none" w="med" len="med"/>
+                    </a:lnL>
+                    <a:lnR w="6350" cap="flat" cmpd="sng" algn="ctr">
+                      <a:solidFill>
+                        <a:srgbClr val="E7EEF2"/>
+                      </a:solidFill>
+                      <a:prstDash val="solid"/>
+                      <a:round/>
+                      <a:headEnd type="none" w="med" len="med"/>
+                      <a:tailEnd type="none" w="med" len="med"/>
+                    </a:lnR>
+                    <a:lnT w="6350" cap="flat" cmpd="sng" algn="ctr">
+                      <a:solidFill>
+                        <a:srgbClr val="E7EEF2"/>
+                      </a:solidFill>
+                      <a:prstDash val="solid"/>
+                      <a:round/>
+                      <a:headEnd type="none" w="med" len="med"/>
+                      <a:tailEnd type="none" w="med" len="med"/>
+                    </a:lnT>
+                    <a:lnB w="6350" cap="flat" cmpd="sng" algn="ctr">
+                      <a:solidFill>
+                        <a:srgbClr val="E7EEF2"/>
+                      </a:solidFill>
+                      <a:prstDash val="solid"/>
+                      <a:round/>
+                      <a:headEnd type="none" w="med" len="med"/>
+                      <a:tailEnd type="none" w="med" len="med"/>
+                    </a:lnB>
+                    <a:solidFill>
+                      <a:srgbClr val="F4F7F9"/>
+                    </a:solidFill>
+                  </a:tcPr>
+                </a:tc>
+                <a:tc>
+                  <a:txBody>
+                    <a:bodyPr/>
+                    <a:lstStyle/>
+                    <a:p>
+                      <a:pPr algn="l" indent="0" marL="0">
+                        <a:buNone/>
+                      </a:pPr>
+                      <a:r>
+                        <a:rPr lang="en-US" sz="1000" b="1" dirty="0">
+                          <a:solidFill>
+                            <a:srgbClr val="64748B"/>
+                          </a:solidFill>
+                          <a:latin typeface="Courier New" pitchFamily="34" charset="0"/>
+                          <a:ea typeface="Courier New" pitchFamily="34" charset="-122"/>
+                          <a:cs typeface="Courier New" pitchFamily="34" charset="-120"/>
+                        </a:rPr>
+                        <a:t>WEIGHT</a:t>
+                      </a:r>
+                    </a:p>
+                  </a:txBody>
+                  <a:tcPr marL="76200" marR="76200" marT="25400" marB="25400" anchor="ctr">
+                    <a:lnL w="6350" cap="flat" cmpd="sng" algn="ctr">
+                      <a:solidFill>
+                        <a:srgbClr val="E7EEF2"/>
+                      </a:solidFill>
+                      <a:prstDash val="solid"/>
+                      <a:round/>
+                      <a:headEnd type="none" w="med" len="med"/>
+                      <a:tailEnd type="none" w="med" len="med"/>
+                    </a:lnL>
+                    <a:lnR w="6350" cap="flat" cmpd="sng" algn="ctr">
+                      <a:solidFill>
+                        <a:srgbClr val="E7EEF2"/>
+                      </a:solidFill>
+                      <a:prstDash val="solid"/>
+                      <a:round/>
+                      <a:headEnd type="none" w="med" len="med"/>
+                      <a:tailEnd type="none" w="med" len="med"/>
+                    </a:lnR>
+                    <a:lnT w="6350" cap="flat" cmpd="sng" algn="ctr">
+                      <a:solidFill>
+                        <a:srgbClr val="E7EEF2"/>
+                      </a:solidFill>
+                      <a:prstDash val="solid"/>
+                      <a:round/>
+                      <a:headEnd type="none" w="med" len="med"/>
+                      <a:tailEnd type="none" w="med" len="med"/>
+                    </a:lnT>
+                    <a:lnB w="6350" cap="flat" cmpd="sng" algn="ctr">
+                      <a:solidFill>
+                        <a:srgbClr val="E7EEF2"/>
+                      </a:solidFill>
+                      <a:prstDash val="solid"/>
+                      <a:round/>
+                      <a:headEnd type="none" w="med" len="med"/>
+                      <a:tailEnd type="none" w="med" len="med"/>
+                    </a:lnB>
+                    <a:solidFill>
+                      <a:srgbClr val="F4F7F9"/>
+                    </a:solidFill>
+                  </a:tcPr>
+                </a:tc>
+                <a:tc>
+                  <a:txBody>
+                    <a:bodyPr/>
+                    <a:lstStyle/>
+                    <a:p>
+                      <a:pPr algn="l" indent="0" marL="0">
+                        <a:buNone/>
+                      </a:pPr>
+                      <a:r>
+                        <a:rPr lang="en-US" sz="1000" b="1" dirty="0">
+                          <a:solidFill>
+                            <a:srgbClr val="64748B"/>
+                          </a:solidFill>
+                          <a:latin typeface="Courier New" pitchFamily="34" charset="0"/>
+                          <a:ea typeface="Courier New" pitchFamily="34" charset="-122"/>
+                          <a:cs typeface="Courier New" pitchFamily="34" charset="-120"/>
+                        </a:rPr>
+                        <a:t>SCORE 0 → 1</a:t>
+                      </a:r>
+                    </a:p>
+                  </a:txBody>
+                  <a:tcPr marL="76200" marR="76200" marT="25400" marB="25400" anchor="ctr">
+                    <a:lnL w="6350" cap="flat" cmpd="sng" algn="ctr">
+                      <a:solidFill>
+                        <a:srgbClr val="E7EEF2"/>
+                      </a:solidFill>
+                      <a:prstDash val="solid"/>
+                      <a:round/>
+                      <a:headEnd type="none" w="med" len="med"/>
+                      <a:tailEnd type="none" w="med" len="med"/>
+                    </a:lnL>
+                    <a:lnR w="6350" cap="flat" cmpd="sng" algn="ctr">
+                      <a:solidFill>
+                        <a:srgbClr val="E7EEF2"/>
+                      </a:solidFill>
+                      <a:prstDash val="solid"/>
+                      <a:round/>
+                      <a:headEnd type="none" w="med" len="med"/>
+                      <a:tailEnd type="none" w="med" len="med"/>
+                    </a:lnR>
+                    <a:lnT w="6350" cap="flat" cmpd="sng" algn="ctr">
+                      <a:solidFill>
+                        <a:srgbClr val="E7EEF2"/>
+                      </a:solidFill>
+                      <a:prstDash val="solid"/>
+                      <a:round/>
+                      <a:headEnd type="none" w="med" len="med"/>
+                      <a:tailEnd type="none" w="med" len="med"/>
+                    </a:lnT>
+                    <a:lnB w="6350" cap="flat" cmpd="sng" algn="ctr">
+                      <a:solidFill>
+                        <a:srgbClr val="E7EEF2"/>
+                      </a:solidFill>
+                      <a:prstDash val="solid"/>
+                      <a:round/>
+                      <a:headEnd type="none" w="med" len="med"/>
+                      <a:tailEnd type="none" w="med" len="med"/>
+                    </a:lnB>
+                    <a:solidFill>
+                      <a:srgbClr val="F4F7F9"/>
+                    </a:solidFill>
+                  </a:tcPr>
+                </a:tc>
+              </a:tr>
+              <a:tr h="365760">
+                <a:tc>
+                  <a:txBody>
+                    <a:bodyPr/>
+                    <a:lstStyle/>
+                    <a:p>
+                      <a:pPr algn="l" indent="0" marL="0">
+                        <a:buNone/>
+                      </a:pPr>
+                      <a:r>
+                        <a:rPr lang="en-US" sz="1150" b="1" dirty="0">
+                          <a:solidFill>
+                            <a:srgbClr val="14213D"/>
+                          </a:solidFill>
+                          <a:latin typeface="Courier New" pitchFamily="34" charset="0"/>
+                          <a:ea typeface="Courier New" pitchFamily="34" charset="-122"/>
+                          <a:cs typeface="Courier New" pitchFamily="34" charset="-120"/>
+                        </a:rPr>
+                        <a:t>stability</a:t>
+                      </a:r>
+                    </a:p>
+                  </a:txBody>
+                  <a:tcPr marL="76200" marR="76200" marT="25400" marB="25400" anchor="ctr">
+                    <a:lnL w="6350" cap="flat" cmpd="sng" algn="ctr">
+                      <a:solidFill>
+                        <a:srgbClr val="E7EEF2"/>
+                      </a:solidFill>
+                      <a:prstDash val="solid"/>
+                      <a:round/>
+                      <a:headEnd type="none" w="med" len="med"/>
+                      <a:tailEnd type="none" w="med" len="med"/>
+                    </a:lnL>
+                    <a:lnR w="6350" cap="flat" cmpd="sng" algn="ctr">
+                      <a:solidFill>
+                        <a:srgbClr val="E7EEF2"/>
+                      </a:solidFill>
+                      <a:prstDash val="solid"/>
+                      <a:round/>
+                      <a:headEnd type="none" w="med" len="med"/>
+                      <a:tailEnd type="none" w="med" len="med"/>
+                    </a:lnR>
+                    <a:lnT w="6350" cap="flat" cmpd="sng" algn="ctr">
+                      <a:solidFill>
+                        <a:srgbClr val="E7EEF2"/>
+                      </a:solidFill>
+                      <a:prstDash val="solid"/>
+                      <a:round/>
+                      <a:headEnd type="none" w="med" len="med"/>
+                      <a:tailEnd type="none" w="med" len="med"/>
+                    </a:lnT>
+                    <a:lnB w="6350" cap="flat" cmpd="sng" algn="ctr">
+                      <a:solidFill>
+                        <a:srgbClr val="E7EEF2"/>
+                      </a:solidFill>
+                      <a:prstDash val="solid"/>
+                      <a:round/>
+                      <a:headEnd type="none" w="med" len="med"/>
+                      <a:tailEnd type="none" w="med" len="med"/>
+                    </a:lnB>
+                    <a:solidFill>
+                      <a:srgbClr val="FFFFFF"/>
+                    </a:solidFill>
+                  </a:tcPr>
+                </a:tc>
+                <a:tc>
+                  <a:txBody>
+                    <a:bodyPr/>
+                    <a:lstStyle/>
+                    <a:p>
+                      <a:pPr algn="l" indent="0" marL="0">
+                        <a:buNone/>
+                      </a:pPr>
+                      <a:r>
+                        <a:rPr lang="en-US" sz="1150" dirty="0">
+                          <a:solidFill>
+                            <a:srgbClr val="33415C"/>
+                          </a:solidFill>
+                          <a:latin typeface="Courier New" pitchFamily="34" charset="0"/>
+                          <a:ea typeface="Courier New" pitchFamily="34" charset="-122"/>
+                          <a:cs typeface="Courier New" pitchFamily="34" charset="-120"/>
+                        </a:rPr>
+                        <a:t>0.25</a:t>
+                      </a:r>
+                    </a:p>
+                  </a:txBody>
+                  <a:tcPr marL="76200" marR="76200" marT="25400" marB="25400" anchor="ctr">
+                    <a:lnL w="6350" cap="flat" cmpd="sng" algn="ctr">
+                      <a:solidFill>
+                        <a:srgbClr val="E7EEF2"/>
+                      </a:solidFill>
+                      <a:prstDash val="solid"/>
+                      <a:round/>
+                      <a:headEnd type="none" w="med" len="med"/>
+                      <a:tailEnd type="none" w="med" len="med"/>
+                    </a:lnL>
+                    <a:lnR w="6350" cap="flat" cmpd="sng" algn="ctr">
+                      <a:solidFill>
+                        <a:srgbClr val="E7EEF2"/>
+                      </a:solidFill>
+                      <a:prstDash val="solid"/>
+                      <a:round/>
+                      <a:headEnd type="none" w="med" len="med"/>
+                      <a:tailEnd type="none" w="med" len="med"/>
+                    </a:lnR>
+                    <a:lnT w="6350" cap="flat" cmpd="sng" algn="ctr">
+                      <a:solidFill>
+                        <a:srgbClr val="E7EEF2"/>
+                      </a:solidFill>
+                      <a:prstDash val="solid"/>
+                      <a:round/>
+                      <a:headEnd type="none" w="med" len="med"/>
+                      <a:tailEnd type="none" w="med" len="med"/>
+                    </a:lnT>
+                    <a:lnB w="6350" cap="flat" cmpd="sng" algn="ctr">
+                      <a:solidFill>
+                        <a:srgbClr val="E7EEF2"/>
+                      </a:solidFill>
+                      <a:prstDash val="solid"/>
+                      <a:round/>
+                      <a:headEnd type="none" w="med" len="med"/>
+                      <a:tailEnd type="none" w="med" len="med"/>
+                    </a:lnB>
+                    <a:solidFill>
+                      <a:srgbClr val="FFFFFF"/>
+                    </a:solidFill>
+                  </a:tcPr>
+                </a:tc>
+                <a:tc>
+                  <a:txBody>
+                    <a:bodyPr/>
+                    <a:lstStyle/>
+                    <a:p>
+                      <a:pPr algn="l" indent="0" marL="0">
+                        <a:buNone/>
+                      </a:pPr>
+                      <a:r>
+                        <a:rPr lang="en-US" sz="1100" dirty="0">
+                          <a:solidFill>
+                            <a:srgbClr val="33415C"/>
+                          </a:solidFill>
+                          <a:latin typeface="Calibri" pitchFamily="34" charset="0"/>
+                          <a:ea typeface="Calibri" pitchFamily="34" charset="-122"/>
+                          <a:cs typeface="Calibri" pitchFamily="34" charset="-120"/>
+                        </a:rPr>
+                        <a:t>1 − E</a:t>
+                      </a:r>
+                      <a:r>
+                        <a:rPr lang="en-US" sz="1100" baseline="-25000" dirty="0">
+                          <a:solidFill>
+                            <a:srgbClr val="33415C"/>
+                          </a:solidFill>
+                          <a:latin typeface="Calibri" pitchFamily="34" charset="0"/>
+                          <a:ea typeface="Calibri" pitchFamily="34" charset="-122"/>
+                          <a:cs typeface="Calibri" pitchFamily="34" charset="-120"/>
+                        </a:rPr>
+                        <a:t>hull</a:t>
+                      </a:r>
+                      <a:r>
+                        <a:rPr lang="en-US" sz="1100" dirty="0">
+                          <a:solidFill>
+                            <a:srgbClr val="33415C"/>
+                          </a:solidFill>
+                          <a:latin typeface="Calibri" pitchFamily="34" charset="0"/>
+                          <a:ea typeface="Calibri" pitchFamily="34" charset="-122"/>
+                          <a:cs typeface="Calibri" pitchFamily="34" charset="-120"/>
+                        </a:rPr>
+                        <a:t> / 0.10 eV/atom, ± OQMD agreement</a:t>
+                      </a:r>
+                    </a:p>
+                  </a:txBody>
+                  <a:tcPr marL="76200" marR="76200" marT="25400" marB="25400" anchor="ctr">
+                    <a:lnL w="6350" cap="flat" cmpd="sng" algn="ctr">
+                      <a:solidFill>
+                        <a:srgbClr val="E7EEF2"/>
+                      </a:solidFill>
+                      <a:prstDash val="solid"/>
+                      <a:round/>
+                      <a:headEnd type="none" w="med" len="med"/>
+                      <a:tailEnd type="none" w="med" len="med"/>
+                    </a:lnL>
+                    <a:lnR w="6350" cap="flat" cmpd="sng" algn="ctr">
+                      <a:solidFill>
+                        <a:srgbClr val="E7EEF2"/>
+                      </a:solidFill>
+                      <a:prstDash val="solid"/>
+                      <a:round/>
+                      <a:headEnd type="none" w="med" len="med"/>
+                      <a:tailEnd type="none" w="med" len="med"/>
+                    </a:lnR>
+                    <a:lnT w="6350" cap="flat" cmpd="sng" algn="ctr">
+                      <a:solidFill>
+                        <a:srgbClr val="E7EEF2"/>
+                      </a:solidFill>
+                      <a:prstDash val="solid"/>
+                      <a:round/>
+                      <a:headEnd type="none" w="med" len="med"/>
+                      <a:tailEnd type="none" w="med" len="med"/>
+                    </a:lnT>
+                    <a:lnB w="6350" cap="flat" cmpd="sng" algn="ctr">
+                      <a:solidFill>
+                        <a:srgbClr val="E7EEF2"/>
+                      </a:solidFill>
+                      <a:prstDash val="solid"/>
+                      <a:round/>
+                      <a:headEnd type="none" w="med" len="med"/>
+                      <a:tailEnd type="none" w="med" len="med"/>
+                    </a:lnB>
+                    <a:solidFill>
+                      <a:srgbClr val="FFFFFF"/>
+                    </a:solidFill>
+                  </a:tcPr>
+                </a:tc>
+              </a:tr>
+              <a:tr h="365760">
+                <a:tc>
+                  <a:txBody>
+                    <a:bodyPr/>
+                    <a:lstStyle/>
+                    <a:p>
+                      <a:pPr algn="l" indent="0" marL="0">
+                        <a:buNone/>
+                      </a:pPr>
+                      <a:r>
+                        <a:rPr lang="en-US" sz="1150" b="1" dirty="0">
+                          <a:solidFill>
+                            <a:srgbClr val="14213D"/>
+                          </a:solidFill>
+                          <a:latin typeface="Courier New" pitchFamily="34" charset="0"/>
+                          <a:ea typeface="Courier New" pitchFamily="34" charset="-122"/>
+                          <a:cs typeface="Courier New" pitchFamily="34" charset="-120"/>
+                        </a:rPr>
+                        <a:t>band gap</a:t>
+                      </a:r>
+                    </a:p>
+                  </a:txBody>
+                  <a:tcPr marL="76200" marR="76200" marT="25400" marB="25400" anchor="ctr">
+                    <a:lnL w="6350" cap="flat" cmpd="sng" algn="ctr">
+                      <a:solidFill>
+                        <a:srgbClr val="E7EEF2"/>
+                      </a:solidFill>
+                      <a:prstDash val="solid"/>
+                      <a:round/>
+                      <a:headEnd type="none" w="med" len="med"/>
+                      <a:tailEnd type="none" w="med" len="med"/>
+                    </a:lnL>
+                    <a:lnR w="6350" cap="flat" cmpd="sng" algn="ctr">
+                      <a:solidFill>
+                        <a:srgbClr val="E7EEF2"/>
+                      </a:solidFill>
+                      <a:prstDash val="solid"/>
+                      <a:round/>
+                      <a:headEnd type="none" w="med" len="med"/>
+                      <a:tailEnd type="none" w="med" len="med"/>
+                    </a:lnR>
+                    <a:lnT w="6350" cap="flat" cmpd="sng" algn="ctr">
+                      <a:solidFill>
+                        <a:srgbClr val="E7EEF2"/>
+                      </a:solidFill>
+                      <a:prstDash val="solid"/>
+                      <a:round/>
+                      <a:headEnd type="none" w="med" len="med"/>
+                      <a:tailEnd type="none" w="med" len="med"/>
+                    </a:lnT>
+                    <a:lnB w="6350" cap="flat" cmpd="sng" algn="ctr">
+                      <a:solidFill>
+                        <a:srgbClr val="E7EEF2"/>
+                      </a:solidFill>
+                      <a:prstDash val="solid"/>
+                      <a:round/>
+                      <a:headEnd type="none" w="med" len="med"/>
+                      <a:tailEnd type="none" w="med" len="med"/>
+                    </a:lnB>
+                    <a:solidFill>
+                      <a:srgbClr val="FFFFFF"/>
+                    </a:solidFill>
+                  </a:tcPr>
+                </a:tc>
+                <a:tc>
+                  <a:txBody>
+                    <a:bodyPr/>
+                    <a:lstStyle/>
+                    <a:p>
+                      <a:pPr algn="l" indent="0" marL="0">
+                        <a:buNone/>
+                      </a:pPr>
+                      <a:r>
+                        <a:rPr lang="en-US" sz="1150" dirty="0">
+                          <a:solidFill>
+                            <a:srgbClr val="33415C"/>
+                          </a:solidFill>
+                          <a:latin typeface="Courier New" pitchFamily="34" charset="0"/>
+                          <a:ea typeface="Courier New" pitchFamily="34" charset="-122"/>
+                          <a:cs typeface="Courier New" pitchFamily="34" charset="-120"/>
+                        </a:rPr>
+                        <a:t>0.25</a:t>
+                      </a:r>
+                    </a:p>
+                  </a:txBody>
+                  <a:tcPr marL="76200" marR="76200" marT="25400" marB="25400" anchor="ctr">
+                    <a:lnL w="6350" cap="flat" cmpd="sng" algn="ctr">
+                      <a:solidFill>
+                        <a:srgbClr val="E7EEF2"/>
+                      </a:solidFill>
+                      <a:prstDash val="solid"/>
+                      <a:round/>
+                      <a:headEnd type="none" w="med" len="med"/>
+                      <a:tailEnd type="none" w="med" len="med"/>
+                    </a:lnL>
+                    <a:lnR w="6350" cap="flat" cmpd="sng" algn="ctr">
+                      <a:solidFill>
+                        <a:srgbClr val="E7EEF2"/>
+                      </a:solidFill>
+                      <a:prstDash val="solid"/>
+                      <a:round/>
+                      <a:headEnd type="none" w="med" len="med"/>
+                      <a:tailEnd type="none" w="med" len="med"/>
+                    </a:lnR>
+                    <a:lnT w="6350" cap="flat" cmpd="sng" algn="ctr">
+                      <a:solidFill>
+                        <a:srgbClr val="E7EEF2"/>
+                      </a:solidFill>
+                      <a:prstDash val="solid"/>
+                      <a:round/>
+                      <a:headEnd type="none" w="med" len="med"/>
+                      <a:tailEnd type="none" w="med" len="med"/>
+                    </a:lnT>
+                    <a:lnB w="6350" cap="flat" cmpd="sng" algn="ctr">
+                      <a:solidFill>
+                        <a:srgbClr val="E7EEF2"/>
+                      </a:solidFill>
+                      <a:prstDash val="solid"/>
+                      <a:round/>
+                      <a:headEnd type="none" w="med" len="med"/>
+                      <a:tailEnd type="none" w="med" len="med"/>
+                    </a:lnB>
+                    <a:solidFill>
+                      <a:srgbClr val="FFFFFF"/>
+                    </a:solidFill>
+                  </a:tcPr>
+                </a:tc>
+                <a:tc>
+                  <a:txBody>
+                    <a:bodyPr/>
+                    <a:lstStyle/>
+                    <a:p>
+                      <a:pPr algn="l" indent="0" marL="0">
+                        <a:buNone/>
+                      </a:pPr>
+                      <a:r>
+                        <a:rPr lang="en-US" sz="1100" dirty="0">
+                          <a:solidFill>
+                            <a:srgbClr val="33415C"/>
+                          </a:solidFill>
+                          <a:latin typeface="Calibri" pitchFamily="34" charset="0"/>
+                          <a:ea typeface="Calibri" pitchFamily="34" charset="-122"/>
+                          <a:cs typeface="Calibri" pitchFamily="34" charset="-120"/>
+                        </a:rPr>
+                        <a:t>4.0 eV gate → 1 at 5.5 eV effective; PBE × 1.4</a:t>
+                      </a:r>
+                    </a:p>
+                  </a:txBody>
+                  <a:tcPr marL="76200" marR="76200" marT="25400" marB="25400" anchor="ctr">
+                    <a:lnL w="6350" cap="flat" cmpd="sng" algn="ctr">
+                      <a:solidFill>
+                        <a:srgbClr val="E7EEF2"/>
+                      </a:solidFill>
+                      <a:prstDash val="solid"/>
+                      <a:round/>
+                      <a:headEnd type="none" w="med" len="med"/>
+                      <a:tailEnd type="none" w="med" len="med"/>
+                    </a:lnL>
+                    <a:lnR w="6350" cap="flat" cmpd="sng" algn="ctr">
+                      <a:solidFill>
+                        <a:srgbClr val="E7EEF2"/>
+                      </a:solidFill>
+                      <a:prstDash val="solid"/>
+                      <a:round/>
+                      <a:headEnd type="none" w="med" len="med"/>
+                      <a:tailEnd type="none" w="med" len="med"/>
+                    </a:lnR>
+                    <a:lnT w="6350" cap="flat" cmpd="sng" algn="ctr">
+                      <a:solidFill>
+                        <a:srgbClr val="E7EEF2"/>
+                      </a:solidFill>
+                      <a:prstDash val="solid"/>
+                      <a:round/>
+                      <a:headEnd type="none" w="med" len="med"/>
+                      <a:tailEnd type="none" w="med" len="med"/>
+                    </a:lnT>
+                    <a:lnB w="6350" cap="flat" cmpd="sng" algn="ctr">
+                      <a:solidFill>
+                        <a:srgbClr val="E7EEF2"/>
+                      </a:solidFill>
+                      <a:prstDash val="solid"/>
+                      <a:round/>
+                      <a:headEnd type="none" w="med" len="med"/>
+                      <a:tailEnd type="none" w="med" len="med"/>
+                    </a:lnB>
+                    <a:solidFill>
+                      <a:srgbClr val="FFFFFF"/>
+                    </a:solidFill>
+                  </a:tcPr>
+                </a:tc>
+              </a:tr>
+              <a:tr h="365760">
+                <a:tc>
+                  <a:txBody>
+                    <a:bodyPr/>
+                    <a:lstStyle/>
+                    <a:p>
+                      <a:pPr algn="l" indent="0" marL="0">
+                        <a:buNone/>
+                      </a:pPr>
+                      <a:r>
+                        <a:rPr lang="en-US" sz="1150" b="1" dirty="0">
+                          <a:solidFill>
+                            <a:srgbClr val="14213D"/>
+                          </a:solidFill>
+                          <a:latin typeface="Courier New" pitchFamily="34" charset="0"/>
+                          <a:ea typeface="Courier New" pitchFamily="34" charset="-122"/>
+                          <a:cs typeface="Courier New" pitchFamily="34" charset="-120"/>
+                        </a:rPr>
+                        <a:t>interface</a:t>
+                      </a:r>
+                    </a:p>
+                  </a:txBody>
+                  <a:tcPr marL="76200" marR="76200" marT="25400" marB="25400" anchor="ctr">
+                    <a:lnL w="6350" cap="flat" cmpd="sng" algn="ctr">
+                      <a:solidFill>
+                        <a:srgbClr val="E7EEF2"/>
+                      </a:solidFill>
+                      <a:prstDash val="solid"/>
+                      <a:round/>
+                      <a:headEnd type="none" w="med" len="med"/>
+                      <a:tailEnd type="none" w="med" len="med"/>
+                    </a:lnL>
+                    <a:lnR w="6350" cap="flat" cmpd="sng" algn="ctr">
+                      <a:solidFill>
+                        <a:srgbClr val="E7EEF2"/>
+                      </a:solidFill>
+                      <a:prstDash val="solid"/>
+                      <a:round/>
+                      <a:headEnd type="none" w="med" len="med"/>
+                      <a:tailEnd type="none" w="med" len="med"/>
+                    </a:lnR>
+                    <a:lnT w="6350" cap="flat" cmpd="sng" algn="ctr">
+                      <a:solidFill>
+                        <a:srgbClr val="E7EEF2"/>
+                      </a:solidFill>
+                      <a:prstDash val="solid"/>
+                      <a:round/>
+                      <a:headEnd type="none" w="med" len="med"/>
+                      <a:tailEnd type="none" w="med" len="med"/>
+                    </a:lnT>
+                    <a:lnB w="6350" cap="flat" cmpd="sng" algn="ctr">
+                      <a:solidFill>
+                        <a:srgbClr val="E7EEF2"/>
+                      </a:solidFill>
+                      <a:prstDash val="solid"/>
+                      <a:round/>
+                      <a:headEnd type="none" w="med" len="med"/>
+                      <a:tailEnd type="none" w="med" len="med"/>
+                    </a:lnB>
+                    <a:solidFill>
+                      <a:srgbClr val="FFFFFF"/>
+                    </a:solidFill>
+                  </a:tcPr>
+                </a:tc>
+                <a:tc>
+                  <a:txBody>
+                    <a:bodyPr/>
+                    <a:lstStyle/>
+                    <a:p>
+                      <a:pPr algn="l" indent="0" marL="0">
+                        <a:buNone/>
+                      </a:pPr>
+                      <a:r>
+                        <a:rPr lang="en-US" sz="1150" dirty="0">
+                          <a:solidFill>
+                            <a:srgbClr val="33415C"/>
+                          </a:solidFill>
+                          <a:latin typeface="Courier New" pitchFamily="34" charset="0"/>
+                          <a:ea typeface="Courier New" pitchFamily="34" charset="-122"/>
+                          <a:cs typeface="Courier New" pitchFamily="34" charset="-120"/>
+                        </a:rPr>
+                        <a:t>0.15</a:t>
+                      </a:r>
+                    </a:p>
+                  </a:txBody>
+                  <a:tcPr marL="76200" marR="76200" marT="25400" marB="25400" anchor="ctr">
+                    <a:lnL w="6350" cap="flat" cmpd="sng" algn="ctr">
+                      <a:solidFill>
+                        <a:srgbClr val="E7EEF2"/>
+                      </a:solidFill>
+                      <a:prstDash val="solid"/>
+                      <a:round/>
+                      <a:headEnd type="none" w="med" len="med"/>
+                      <a:tailEnd type="none" w="med" len="med"/>
+                    </a:lnL>
+                    <a:lnR w="6350" cap="flat" cmpd="sng" algn="ctr">
+                      <a:solidFill>
+                        <a:srgbClr val="E7EEF2"/>
+                      </a:solidFill>
+                      <a:prstDash val="solid"/>
+                      <a:round/>
+                      <a:headEnd type="none" w="med" len="med"/>
+                      <a:tailEnd type="none" w="med" len="med"/>
+                    </a:lnR>
+                    <a:lnT w="6350" cap="flat" cmpd="sng" algn="ctr">
+                      <a:solidFill>
+                        <a:srgbClr val="E7EEF2"/>
+                      </a:solidFill>
+                      <a:prstDash val="solid"/>
+                      <a:round/>
+                      <a:headEnd type="none" w="med" len="med"/>
+                      <a:tailEnd type="none" w="med" len="med"/>
+                    </a:lnT>
+                    <a:lnB w="6350" cap="flat" cmpd="sng" algn="ctr">
+                      <a:solidFill>
+                        <a:srgbClr val="E7EEF2"/>
+                      </a:solidFill>
+                      <a:prstDash val="solid"/>
+                      <a:round/>
+                      <a:headEnd type="none" w="med" len="med"/>
+                      <a:tailEnd type="none" w="med" len="med"/>
+                    </a:lnB>
+                    <a:solidFill>
+                      <a:srgbClr val="FFFFFF"/>
+                    </a:solidFill>
+                  </a:tcPr>
+                </a:tc>
+                <a:tc>
+                  <a:txBody>
+                    <a:bodyPr/>
+                    <a:lstStyle/>
+                    <a:p>
+                      <a:pPr algn="l" indent="0" marL="0">
+                        <a:buNone/>
+                      </a:pPr>
+                      <a:r>
+                        <a:rPr lang="en-US" sz="1100" dirty="0">
+                          <a:solidFill>
+                            <a:srgbClr val="33415C"/>
+                          </a:solidFill>
+                          <a:latin typeface="Calibri" pitchFamily="34" charset="0"/>
+                          <a:ea typeface="Calibri" pitchFamily="34" charset="-122"/>
+                          <a:cs typeface="Calibri" pitchFamily="34" charset="-120"/>
+                        </a:rPr>
+                        <a:t>Si hull reaction; ≤ 0.05 eV/atom is none, 0 at −0.25</a:t>
+                      </a:r>
+                    </a:p>
+                  </a:txBody>
+                  <a:tcPr marL="76200" marR="76200" marT="25400" marB="25400" anchor="ctr">
+                    <a:lnL w="6350" cap="flat" cmpd="sng" algn="ctr">
+                      <a:solidFill>
+                        <a:srgbClr val="E7EEF2"/>
+                      </a:solidFill>
+                      <a:prstDash val="solid"/>
+                      <a:round/>
+                      <a:headEnd type="none" w="med" len="med"/>
+                      <a:tailEnd type="none" w="med" len="med"/>
+                    </a:lnL>
+                    <a:lnR w="6350" cap="flat" cmpd="sng" algn="ctr">
+                      <a:solidFill>
+                        <a:srgbClr val="E7EEF2"/>
+                      </a:solidFill>
+                      <a:prstDash val="solid"/>
+                      <a:round/>
+                      <a:headEnd type="none" w="med" len="med"/>
+                      <a:tailEnd type="none" w="med" len="med"/>
+                    </a:lnR>
+                    <a:lnT w="6350" cap="flat" cmpd="sng" algn="ctr">
+                      <a:solidFill>
+                        <a:srgbClr val="E7EEF2"/>
+                      </a:solidFill>
+                      <a:prstDash val="solid"/>
+                      <a:round/>
+                      <a:headEnd type="none" w="med" len="med"/>
+                      <a:tailEnd type="none" w="med" len="med"/>
+                    </a:lnT>
+                    <a:lnB w="6350" cap="flat" cmpd="sng" algn="ctr">
+                      <a:solidFill>
+                        <a:srgbClr val="E7EEF2"/>
+                      </a:solidFill>
+                      <a:prstDash val="solid"/>
+                      <a:round/>
+                      <a:headEnd type="none" w="med" len="med"/>
+                      <a:tailEnd type="none" w="med" len="med"/>
+                    </a:lnB>
+                    <a:solidFill>
+                      <a:srgbClr val="FFFFFF"/>
+                    </a:solidFill>
+                  </a:tcPr>
+                </a:tc>
+              </a:tr>
+              <a:tr h="365760">
+                <a:tc>
+                  <a:txBody>
+                    <a:bodyPr/>
+                    <a:lstStyle/>
+                    <a:p>
+                      <a:pPr algn="l" indent="0" marL="0">
+                        <a:buNone/>
+                      </a:pPr>
+                      <a:r>
+                        <a:rPr lang="en-US" sz="1150" b="1" dirty="0">
+                          <a:solidFill>
+                            <a:srgbClr val="14213D"/>
+                          </a:solidFill>
+                          <a:latin typeface="Courier New" pitchFamily="34" charset="0"/>
+                          <a:ea typeface="Courier New" pitchFamily="34" charset="-122"/>
+                          <a:cs typeface="Courier New" pitchFamily="34" charset="-120"/>
+                        </a:rPr>
+                        <a:t>toxicity</a:t>
+                      </a:r>
+                    </a:p>
+                  </a:txBody>
+                  <a:tcPr marL="76200" marR="76200" marT="25400" marB="25400" anchor="ctr">
+                    <a:lnL w="6350" cap="flat" cmpd="sng" algn="ctr">
+                      <a:solidFill>
+                        <a:srgbClr val="E7EEF2"/>
+                      </a:solidFill>
+                      <a:prstDash val="solid"/>
+                      <a:round/>
+                      <a:headEnd type="none" w="med" len="med"/>
+                      <a:tailEnd type="none" w="med" len="med"/>
+                    </a:lnL>
+                    <a:lnR w="6350" cap="flat" cmpd="sng" algn="ctr">
+                      <a:solidFill>
+                        <a:srgbClr val="E7EEF2"/>
+                      </a:solidFill>
+                      <a:prstDash val="solid"/>
+                      <a:round/>
+                      <a:headEnd type="none" w="med" len="med"/>
+                      <a:tailEnd type="none" w="med" len="med"/>
+                    </a:lnR>
+                    <a:lnT w="6350" cap="flat" cmpd="sng" algn="ctr">
+                      <a:solidFill>
+                        <a:srgbClr val="E7EEF2"/>
+                      </a:solidFill>
+                      <a:prstDash val="solid"/>
+                      <a:round/>
+                      <a:headEnd type="none" w="med" len="med"/>
+                      <a:tailEnd type="none" w="med" len="med"/>
+                    </a:lnT>
+                    <a:lnB w="6350" cap="flat" cmpd="sng" algn="ctr">
+                      <a:solidFill>
+                        <a:srgbClr val="E7EEF2"/>
+                      </a:solidFill>
+                      <a:prstDash val="solid"/>
+                      <a:round/>
+                      <a:headEnd type="none" w="med" len="med"/>
+                      <a:tailEnd type="none" w="med" len="med"/>
+                    </a:lnB>
+                    <a:solidFill>
+                      <a:srgbClr val="FFFFFF"/>
+                    </a:solidFill>
+                  </a:tcPr>
+                </a:tc>
+                <a:tc>
+                  <a:txBody>
+                    <a:bodyPr/>
+                    <a:lstStyle/>
+                    <a:p>
+                      <a:pPr algn="l" indent="0" marL="0">
+                        <a:buNone/>
+                      </a:pPr>
+                      <a:r>
+                        <a:rPr lang="en-US" sz="1150" dirty="0">
+                          <a:solidFill>
+                            <a:srgbClr val="33415C"/>
+                          </a:solidFill>
+                          <a:latin typeface="Courier New" pitchFamily="34" charset="0"/>
+                          <a:ea typeface="Courier New" pitchFamily="34" charset="-122"/>
+                          <a:cs typeface="Courier New" pitchFamily="34" charset="-120"/>
+                        </a:rPr>
+                        <a:t>0.15</a:t>
+                      </a:r>
+                    </a:p>
+                  </a:txBody>
+                  <a:tcPr marL="76200" marR="76200" marT="25400" marB="25400" anchor="ctr">
+                    <a:lnL w="6350" cap="flat" cmpd="sng" algn="ctr">
+                      <a:solidFill>
+                        <a:srgbClr val="E7EEF2"/>
+                      </a:solidFill>
+                      <a:prstDash val="solid"/>
+                      <a:round/>
+                      <a:headEnd type="none" w="med" len="med"/>
+                      <a:tailEnd type="none" w="med" len="med"/>
+                    </a:lnL>
+                    <a:lnR w="6350" cap="flat" cmpd="sng" algn="ctr">
+                      <a:solidFill>
+                        <a:srgbClr val="E7EEF2"/>
+                      </a:solidFill>
+                      <a:prstDash val="solid"/>
+                      <a:round/>
+                      <a:headEnd type="none" w="med" len="med"/>
+                      <a:tailEnd type="none" w="med" len="med"/>
+                    </a:lnR>
+                    <a:lnT w="6350" cap="flat" cmpd="sng" algn="ctr">
+                      <a:solidFill>
+                        <a:srgbClr val="E7EEF2"/>
+                      </a:solidFill>
+                      <a:prstDash val="solid"/>
+                      <a:round/>
+                      <a:headEnd type="none" w="med" len="med"/>
+                      <a:tailEnd type="none" w="med" len="med"/>
+                    </a:lnT>
+                    <a:lnB w="6350" cap="flat" cmpd="sng" algn="ctr">
+                      <a:solidFill>
+                        <a:srgbClr val="E7EEF2"/>
+                      </a:solidFill>
+                      <a:prstDash val="solid"/>
+                      <a:round/>
+                      <a:headEnd type="none" w="med" len="med"/>
+                      <a:tailEnd type="none" w="med" len="med"/>
+                    </a:lnB>
+                    <a:solidFill>
+                      <a:srgbClr val="FFFFFF"/>
+                    </a:solidFill>
+                  </a:tcPr>
+                </a:tc>
+                <a:tc>
+                  <a:txBody>
+                    <a:bodyPr/>
+                    <a:lstStyle/>
+                    <a:p>
+                      <a:pPr algn="l" indent="0" marL="0">
+                        <a:buNone/>
+                      </a:pPr>
+                      <a:r>
+                        <a:rPr lang="en-US" sz="1100" dirty="0">
+                          <a:solidFill>
+                            <a:srgbClr val="33415C"/>
+                          </a:solidFill>
+                          <a:latin typeface="Calibri" pitchFamily="34" charset="0"/>
+                          <a:ea typeface="Calibri" pitchFamily="34" charset="-122"/>
+                          <a:cs typeface="Calibri" pitchFamily="34" charset="-120"/>
+                        </a:rPr>
+                        <a:t>worst element tier: 0 → 1.0, 1 → 0.5, 2 → 0</a:t>
+                      </a:r>
+                    </a:p>
+                  </a:txBody>
+                  <a:tcPr marL="76200" marR="76200" marT="25400" marB="25400" anchor="ctr">
+                    <a:lnL w="6350" cap="flat" cmpd="sng" algn="ctr">
+                      <a:solidFill>
+                        <a:srgbClr val="E7EEF2"/>
+                      </a:solidFill>
+                      <a:prstDash val="solid"/>
+                      <a:round/>
+                      <a:headEnd type="none" w="med" len="med"/>
+                      <a:tailEnd type="none" w="med" len="med"/>
+                    </a:lnL>
+                    <a:lnR w="6350" cap="flat" cmpd="sng" algn="ctr">
+                      <a:solidFill>
+                        <a:srgbClr val="E7EEF2"/>
+                      </a:solidFill>
+                      <a:prstDash val="solid"/>
+                      <a:round/>
+                      <a:headEnd type="none" w="med" len="med"/>
+                      <a:tailEnd type="none" w="med" len="med"/>
+                    </a:lnR>
+                    <a:lnT w="6350" cap="flat" cmpd="sng" algn="ctr">
+                      <a:solidFill>
+                        <a:srgbClr val="E7EEF2"/>
+                      </a:solidFill>
+                      <a:prstDash val="solid"/>
+                      <a:round/>
+                      <a:headEnd type="none" w="med" len="med"/>
+                      <a:tailEnd type="none" w="med" len="med"/>
+                    </a:lnT>
+                    <a:lnB w="6350" cap="flat" cmpd="sng" algn="ctr">
+                      <a:solidFill>
+                        <a:srgbClr val="E7EEF2"/>
+                      </a:solidFill>
+                      <a:prstDash val="solid"/>
+                      <a:round/>
+                      <a:headEnd type="none" w="med" len="med"/>
+                      <a:tailEnd type="none" w="med" len="med"/>
+                    </a:lnB>
+                    <a:solidFill>
+                      <a:srgbClr val="FFFFFF"/>
+                    </a:solidFill>
+                  </a:tcPr>
+                </a:tc>
+              </a:tr>
+              <a:tr h="365760">
+                <a:tc>
+                  <a:txBody>
+                    <a:bodyPr/>
+                    <a:lstStyle/>
+                    <a:p>
+                      <a:pPr algn="l" indent="0" marL="0">
+                        <a:buNone/>
+                      </a:pPr>
+                      <a:r>
+                        <a:rPr lang="en-US" sz="1150" b="1" dirty="0">
+                          <a:solidFill>
+                            <a:srgbClr val="14213D"/>
+                          </a:solidFill>
+                          <a:latin typeface="Courier New" pitchFamily="34" charset="0"/>
+                          <a:ea typeface="Courier New" pitchFamily="34" charset="-122"/>
+                          <a:cs typeface="Courier New" pitchFamily="34" charset="-120"/>
+                        </a:rPr>
+                        <a:t>simplicity</a:t>
+                      </a:r>
+                    </a:p>
+                  </a:txBody>
+                  <a:tcPr marL="76200" marR="76200" marT="25400" marB="25400" anchor="ctr">
+                    <a:lnL w="6350" cap="flat" cmpd="sng" algn="ctr">
+                      <a:solidFill>
+                        <a:srgbClr val="E7EEF2"/>
+                      </a:solidFill>
+                      <a:prstDash val="solid"/>
+                      <a:round/>
+                      <a:headEnd type="none" w="med" len="med"/>
+                      <a:tailEnd type="none" w="med" len="med"/>
+                    </a:lnL>
+                    <a:lnR w="6350" cap="flat" cmpd="sng" algn="ctr">
+                      <a:solidFill>
+                        <a:srgbClr val="E7EEF2"/>
+                      </a:solidFill>
+                      <a:prstDash val="solid"/>
+                      <a:round/>
+                      <a:headEnd type="none" w="med" len="med"/>
+                      <a:tailEnd type="none" w="med" len="med"/>
+                    </a:lnR>
+                    <a:lnT w="6350" cap="flat" cmpd="sng" algn="ctr">
+                      <a:solidFill>
+                        <a:srgbClr val="E7EEF2"/>
+                      </a:solidFill>
+                      <a:prstDash val="solid"/>
+                      <a:round/>
+                      <a:headEnd type="none" w="med" len="med"/>
+                      <a:tailEnd type="none" w="med" len="med"/>
+                    </a:lnT>
+                    <a:lnB w="6350" cap="flat" cmpd="sng" algn="ctr">
+                      <a:solidFill>
+                        <a:srgbClr val="E7EEF2"/>
+                      </a:solidFill>
+                      <a:prstDash val="solid"/>
+                      <a:round/>
+                      <a:headEnd type="none" w="med" len="med"/>
+                      <a:tailEnd type="none" w="med" len="med"/>
+                    </a:lnB>
+                    <a:solidFill>
+                      <a:srgbClr val="FFFFFF"/>
+                    </a:solidFill>
+                  </a:tcPr>
+                </a:tc>
+                <a:tc>
+                  <a:txBody>
+                    <a:bodyPr/>
+                    <a:lstStyle/>
+                    <a:p>
+                      <a:pPr algn="l" indent="0" marL="0">
+                        <a:buNone/>
+                      </a:pPr>
+                      <a:r>
+                        <a:rPr lang="en-US" sz="1150" dirty="0">
+                          <a:solidFill>
+                            <a:srgbClr val="33415C"/>
+                          </a:solidFill>
+                          <a:latin typeface="Courier New" pitchFamily="34" charset="0"/>
+                          <a:ea typeface="Courier New" pitchFamily="34" charset="-122"/>
+                          <a:cs typeface="Courier New" pitchFamily="34" charset="-120"/>
+                        </a:rPr>
+                        <a:t>0.10</a:t>
+                      </a:r>
+                    </a:p>
+                  </a:txBody>
+                  <a:tcPr marL="76200" marR="76200" marT="25400" marB="25400" anchor="ctr">
+                    <a:lnL w="6350" cap="flat" cmpd="sng" algn="ctr">
+                      <a:solidFill>
+                        <a:srgbClr val="E7EEF2"/>
+                      </a:solidFill>
+                      <a:prstDash val="solid"/>
+                      <a:round/>
+                      <a:headEnd type="none" w="med" len="med"/>
+                      <a:tailEnd type="none" w="med" len="med"/>
+                    </a:lnL>
+                    <a:lnR w="6350" cap="flat" cmpd="sng" algn="ctr">
+                      <a:solidFill>
+                        <a:srgbClr val="E7EEF2"/>
+                      </a:solidFill>
+                      <a:prstDash val="solid"/>
+                      <a:round/>
+                      <a:headEnd type="none" w="med" len="med"/>
+                      <a:tailEnd type="none" w="med" len="med"/>
+                    </a:lnR>
+                    <a:lnT w="6350" cap="flat" cmpd="sng" algn="ctr">
+                      <a:solidFill>
+                        <a:srgbClr val="E7EEF2"/>
+                      </a:solidFill>
+                      <a:prstDash val="solid"/>
+                      <a:round/>
+                      <a:headEnd type="none" w="med" len="med"/>
+                      <a:tailEnd type="none" w="med" len="med"/>
+                    </a:lnT>
+                    <a:lnB w="6350" cap="flat" cmpd="sng" algn="ctr">
+                      <a:solidFill>
+                        <a:srgbClr val="E7EEF2"/>
+                      </a:solidFill>
+                      <a:prstDash val="solid"/>
+                      <a:round/>
+                      <a:headEnd type="none" w="med" len="med"/>
+                      <a:tailEnd type="none" w="med" len="med"/>
+                    </a:lnB>
+                    <a:solidFill>
+                      <a:srgbClr val="FFFFFF"/>
+                    </a:solidFill>
+                  </a:tcPr>
+                </a:tc>
+                <a:tc>
+                  <a:txBody>
+                    <a:bodyPr/>
+                    <a:lstStyle/>
+                    <a:p>
+                      <a:pPr algn="l" indent="0" marL="0">
+                        <a:buNone/>
+                      </a:pPr>
+                      <a:r>
+                        <a:rPr lang="en-US" sz="1100" dirty="0">
+                          <a:solidFill>
+                            <a:srgbClr val="33415C"/>
+                          </a:solidFill>
+                          <a:latin typeface="Calibri" pitchFamily="34" charset="0"/>
+                          <a:ea typeface="Calibri" pitchFamily="34" charset="-122"/>
+                          <a:cs typeface="Calibri" pitchFamily="34" charset="-120"/>
+                        </a:rPr>
+                        <a:t>distinct elements: 2 → 1.0, 3 → 0.6, 4 → 0.3</a:t>
+                      </a:r>
+                    </a:p>
+                  </a:txBody>
+                  <a:tcPr marL="76200" marR="76200" marT="25400" marB="25400" anchor="ctr">
+                    <a:lnL w="6350" cap="flat" cmpd="sng" algn="ctr">
+                      <a:solidFill>
+                        <a:srgbClr val="E7EEF2"/>
+                      </a:solidFill>
+                      <a:prstDash val="solid"/>
+                      <a:round/>
+                      <a:headEnd type="none" w="med" len="med"/>
+                      <a:tailEnd type="none" w="med" len="med"/>
+                    </a:lnL>
+                    <a:lnR w="6350" cap="flat" cmpd="sng" algn="ctr">
+                      <a:solidFill>
+                        <a:srgbClr val="E7EEF2"/>
+                      </a:solidFill>
+                      <a:prstDash val="solid"/>
+                      <a:round/>
+                      <a:headEnd type="none" w="med" len="med"/>
+                      <a:tailEnd type="none" w="med" len="med"/>
+                    </a:lnR>
+                    <a:lnT w="6350" cap="flat" cmpd="sng" algn="ctr">
+                      <a:solidFill>
+                        <a:srgbClr val="E7EEF2"/>
+                      </a:solidFill>
+                      <a:prstDash val="solid"/>
+                      <a:round/>
+                      <a:headEnd type="none" w="med" len="med"/>
+                      <a:tailEnd type="none" w="med" len="med"/>
+                    </a:lnT>
+                    <a:lnB w="6350" cap="flat" cmpd="sng" algn="ctr">
+                      <a:solidFill>
+                        <a:srgbClr val="E7EEF2"/>
+                      </a:solidFill>
+                      <a:prstDash val="solid"/>
+                      <a:round/>
+                      <a:headEnd type="none" w="med" len="med"/>
+                      <a:tailEnd type="none" w="med" len="med"/>
+                    </a:lnB>
+                    <a:solidFill>
+                      <a:srgbClr val="FFFFFF"/>
+                    </a:solidFill>
+                  </a:tcPr>
+                </a:tc>
+              </a:tr>
+              <a:tr h="365760">
+                <a:tc>
+                  <a:txBody>
+                    <a:bodyPr/>
+                    <a:lstStyle/>
+                    <a:p>
+                      <a:pPr algn="l" indent="0" marL="0">
+                        <a:buNone/>
+                      </a:pPr>
+                      <a:r>
+                        <a:rPr lang="en-US" sz="1150" b="1" dirty="0">
+                          <a:solidFill>
+                            <a:srgbClr val="14213D"/>
+                          </a:solidFill>
+                          <a:latin typeface="Courier New" pitchFamily="34" charset="0"/>
+                          <a:ea typeface="Courier New" pitchFamily="34" charset="-122"/>
+                          <a:cs typeface="Courier New" pitchFamily="34" charset="-120"/>
+                        </a:rPr>
+                        <a:t>literature</a:t>
+                      </a:r>
+                    </a:p>
+                  </a:txBody>
+                  <a:tcPr marL="76200" marR="76200" marT="25400" marB="25400" anchor="ctr">
+                    <a:lnL w="6350" cap="flat" cmpd="sng" algn="ctr">
+                      <a:solidFill>
+                        <a:srgbClr val="E7EEF2"/>
+                      </a:solidFill>
+                      <a:prstDash val="solid"/>
+                      <a:round/>
+                      <a:headEnd type="none" w="med" len="med"/>
+                      <a:tailEnd type="none" w="med" len="med"/>
+                    </a:lnL>
+                    <a:lnR w="6350" cap="flat" cmpd="sng" algn="ctr">
+                      <a:solidFill>
+                        <a:srgbClr val="E7EEF2"/>
+                      </a:solidFill>
+                      <a:prstDash val="solid"/>
+                      <a:round/>
+                      <a:headEnd type="none" w="med" len="med"/>
+                      <a:tailEnd type="none" w="med" len="med"/>
+                    </a:lnR>
+                    <a:lnT w="6350" cap="flat" cmpd="sng" algn="ctr">
+                      <a:solidFill>
+                        <a:srgbClr val="E7EEF2"/>
+                      </a:solidFill>
+                      <a:prstDash val="solid"/>
+                      <a:round/>
+                      <a:headEnd type="none" w="med" len="med"/>
+                      <a:tailEnd type="none" w="med" len="med"/>
+                    </a:lnT>
+                    <a:lnB w="6350" cap="flat" cmpd="sng" algn="ctr">
+                      <a:solidFill>
+                        <a:srgbClr val="E7EEF2"/>
+                      </a:solidFill>
+                      <a:prstDash val="solid"/>
+                      <a:round/>
+                      <a:headEnd type="none" w="med" len="med"/>
+                      <a:tailEnd type="none" w="med" len="med"/>
+                    </a:lnB>
+                    <a:solidFill>
+                      <a:srgbClr val="FFFFFF"/>
+                    </a:solidFill>
+                  </a:tcPr>
+                </a:tc>
+                <a:tc>
+                  <a:txBody>
+                    <a:bodyPr/>
+                    <a:lstStyle/>
+                    <a:p>
+                      <a:pPr algn="l" indent="0" marL="0">
+                        <a:buNone/>
+                      </a:pPr>
+                      <a:r>
+                        <a:rPr lang="en-US" sz="1150" dirty="0">
+                          <a:solidFill>
+                            <a:srgbClr val="33415C"/>
+                          </a:solidFill>
+                          <a:latin typeface="Courier New" pitchFamily="34" charset="0"/>
+                          <a:ea typeface="Courier New" pitchFamily="34" charset="-122"/>
+                          <a:cs typeface="Courier New" pitchFamily="34" charset="-120"/>
+                        </a:rPr>
+                        <a:t>0.10</a:t>
+                      </a:r>
+                    </a:p>
+                  </a:txBody>
+                  <a:tcPr marL="76200" marR="76200" marT="25400" marB="25400" anchor="ctr">
+                    <a:lnL w="6350" cap="flat" cmpd="sng" algn="ctr">
+                      <a:solidFill>
+                        <a:srgbClr val="E7EEF2"/>
+                      </a:solidFill>
+                      <a:prstDash val="solid"/>
+                      <a:round/>
+                      <a:headEnd type="none" w="med" len="med"/>
+                      <a:tailEnd type="none" w="med" len="med"/>
+                    </a:lnL>
+                    <a:lnR w="6350" cap="flat" cmpd="sng" algn="ctr">
+                      <a:solidFill>
+                        <a:srgbClr val="E7EEF2"/>
+                      </a:solidFill>
+                      <a:prstDash val="solid"/>
+                      <a:round/>
+                      <a:headEnd type="none" w="med" len="med"/>
+                      <a:tailEnd type="none" w="med" len="med"/>
+                    </a:lnR>
+                    <a:lnT w="6350" cap="flat" cmpd="sng" algn="ctr">
+                      <a:solidFill>
+                        <a:srgbClr val="E7EEF2"/>
+                      </a:solidFill>
+                      <a:prstDash val="solid"/>
+                      <a:round/>
+                      <a:headEnd type="none" w="med" len="med"/>
+                      <a:tailEnd type="none" w="med" len="med"/>
+                    </a:lnT>
+                    <a:lnB w="6350" cap="flat" cmpd="sng" algn="ctr">
+                      <a:solidFill>
+                        <a:srgbClr val="E7EEF2"/>
+                      </a:solidFill>
+                      <a:prstDash val="solid"/>
+                      <a:round/>
+                      <a:headEnd type="none" w="med" len="med"/>
+                      <a:tailEnd type="none" w="med" len="med"/>
+                    </a:lnB>
+                    <a:solidFill>
+                      <a:srgbClr val="FFFFFF"/>
+                    </a:solidFill>
+                  </a:tcPr>
+                </a:tc>
+                <a:tc>
+                  <a:txBody>
+                    <a:bodyPr/>
+                    <a:lstStyle/>
+                    <a:p>
+                      <a:pPr algn="l" indent="0" marL="0">
+                        <a:buNone/>
+                      </a:pPr>
+                      <a:r>
+                        <a:rPr lang="en-US" sz="1100" dirty="0">
+                          <a:solidFill>
+                            <a:srgbClr val="33415C"/>
+                          </a:solidFill>
+                          <a:latin typeface="Calibri" pitchFamily="34" charset="0"/>
+                          <a:ea typeface="Calibri" pitchFamily="34" charset="-122"/>
+                          <a:cs typeface="Calibri" pitchFamily="34" charset="-120"/>
+                        </a:rPr>
+                        <a:t>log-saturating, 0.7 thin-film (500) + 0.3 all (5,000)</a:t>
+                      </a:r>
+                    </a:p>
+                  </a:txBody>
+                  <a:tcPr marL="76200" marR="76200" marT="25400" marB="25400" anchor="ctr">
+                    <a:lnL w="6350" cap="flat" cmpd="sng" algn="ctr">
+                      <a:solidFill>
+                        <a:srgbClr val="E7EEF2"/>
+                      </a:solidFill>
+                      <a:prstDash val="solid"/>
+                      <a:round/>
+                      <a:headEnd type="none" w="med" len="med"/>
+                      <a:tailEnd type="none" w="med" len="med"/>
+                    </a:lnL>
+                    <a:lnR w="6350" cap="flat" cmpd="sng" algn="ctr">
+                      <a:solidFill>
+                        <a:srgbClr val="E7EEF2"/>
+                      </a:solidFill>
+                      <a:prstDash val="solid"/>
+                      <a:round/>
+                      <a:headEnd type="none" w="med" len="med"/>
+                      <a:tailEnd type="none" w="med" len="med"/>
+                    </a:lnR>
+                    <a:lnT w="6350" cap="flat" cmpd="sng" algn="ctr">
+                      <a:solidFill>
+                        <a:srgbClr val="E7EEF2"/>
+                      </a:solidFill>
+                      <a:prstDash val="solid"/>
+                      <a:round/>
+                      <a:headEnd type="none" w="med" len="med"/>
+                      <a:tailEnd type="none" w="med" len="med"/>
+                    </a:lnT>
+                    <a:lnB w="6350" cap="flat" cmpd="sng" algn="ctr">
+                      <a:solidFill>
+                        <a:srgbClr val="E7EEF2"/>
+                      </a:solidFill>
+                      <a:prstDash val="solid"/>
+                      <a:round/>
+                      <a:headEnd type="none" w="med" len="med"/>
+                      <a:tailEnd type="none" w="med" len="med"/>
+                    </a:lnB>
+                    <a:solidFill>
+                      <a:srgbClr val="FFFFFF"/>
+                    </a:solidFill>
+                  </a:tcPr>
+                </a:tc>
+              </a:tr>
+              <a:tr h="365760">
+                <a:tc>
+                  <a:txBody>
+                    <a:bodyPr/>
+                    <a:lstStyle/>
+                    <a:p>
+                      <a:pPr algn="l" indent="0" marL="0">
+                        <a:buNone/>
+                      </a:pPr>
+                      <a:r>
+                        <a:rPr lang="en-US" sz="1150" b="1" dirty="0">
+                          <a:solidFill>
+                            <a:srgbClr val="14213D"/>
+                          </a:solidFill>
+                          <a:latin typeface="Courier New" pitchFamily="34" charset="0"/>
+                          <a:ea typeface="Courier New" pitchFamily="34" charset="-122"/>
+                          <a:cs typeface="Courier New" pitchFamily="34" charset="-120"/>
+                        </a:rPr>
+                        <a:t>dielectric κ ★</a:t>
+                      </a:r>
+                    </a:p>
+                  </a:txBody>
+                  <a:tcPr marL="76200" marR="76200" marT="25400" marB="25400" anchor="ctr">
+                    <a:lnL w="6350" cap="flat" cmpd="sng" algn="ctr">
+                      <a:solidFill>
+                        <a:srgbClr val="E7EEF2"/>
+                      </a:solidFill>
+                      <a:prstDash val="solid"/>
+                      <a:round/>
+                      <a:headEnd type="none" w="med" len="med"/>
+                      <a:tailEnd type="none" w="med" len="med"/>
+                    </a:lnL>
+                    <a:lnR w="6350" cap="flat" cmpd="sng" algn="ctr">
+                      <a:solidFill>
+                        <a:srgbClr val="E7EEF2"/>
+                      </a:solidFill>
+                      <a:prstDash val="solid"/>
+                      <a:round/>
+                      <a:headEnd type="none" w="med" len="med"/>
+                      <a:tailEnd type="none" w="med" len="med"/>
+                    </a:lnR>
+                    <a:lnT w="6350" cap="flat" cmpd="sng" algn="ctr">
+                      <a:solidFill>
+                        <a:srgbClr val="E7EEF2"/>
+                      </a:solidFill>
+                      <a:prstDash val="solid"/>
+                      <a:round/>
+                      <a:headEnd type="none" w="med" len="med"/>
+                      <a:tailEnd type="none" w="med" len="med"/>
+                    </a:lnT>
+                    <a:lnB w="6350" cap="flat" cmpd="sng" algn="ctr">
+                      <a:solidFill>
+                        <a:srgbClr val="E7EEF2"/>
+                      </a:solidFill>
+                      <a:prstDash val="solid"/>
+                      <a:round/>
+                      <a:headEnd type="none" w="med" len="med"/>
+                      <a:tailEnd type="none" w="med" len="med"/>
+                    </a:lnB>
+                    <a:solidFill>
+                      <a:srgbClr val="EAF6FB"/>
+                    </a:solidFill>
+                  </a:tcPr>
+                </a:tc>
+                <a:tc>
+                  <a:txBody>
+                    <a:bodyPr/>
+                    <a:lstStyle/>
+                    <a:p>
+                      <a:pPr algn="l" indent="0" marL="0">
+                        <a:buNone/>
+                      </a:pPr>
+                      <a:r>
+                        <a:rPr lang="en-US" sz="1150" dirty="0">
+                          <a:solidFill>
+                            <a:srgbClr val="33415C"/>
+                          </a:solidFill>
+                          <a:latin typeface="Courier New" pitchFamily="34" charset="0"/>
+                          <a:ea typeface="Courier New" pitchFamily="34" charset="-122"/>
+                          <a:cs typeface="Courier New" pitchFamily="34" charset="-120"/>
+                        </a:rPr>
+                        <a:t>0.15</a:t>
+                      </a:r>
+                    </a:p>
+                  </a:txBody>
+                  <a:tcPr marL="76200" marR="76200" marT="25400" marB="25400" anchor="ctr">
+                    <a:lnL w="6350" cap="flat" cmpd="sng" algn="ctr">
+                      <a:solidFill>
+                        <a:srgbClr val="E7EEF2"/>
+                      </a:solidFill>
+                      <a:prstDash val="solid"/>
+                      <a:round/>
+                      <a:headEnd type="none" w="med" len="med"/>
+                      <a:tailEnd type="none" w="med" len="med"/>
+                    </a:lnL>
+                    <a:lnR w="6350" cap="flat" cmpd="sng" algn="ctr">
+                      <a:solidFill>
+                        <a:srgbClr val="E7EEF2"/>
+                      </a:solidFill>
+                      <a:prstDash val="solid"/>
+                      <a:round/>
+                      <a:headEnd type="none" w="med" len="med"/>
+                      <a:tailEnd type="none" w="med" len="med"/>
+                    </a:lnR>
+                    <a:lnT w="6350" cap="flat" cmpd="sng" algn="ctr">
+                      <a:solidFill>
+                        <a:srgbClr val="E7EEF2"/>
+                      </a:solidFill>
+                      <a:prstDash val="solid"/>
+                      <a:round/>
+                      <a:headEnd type="none" w="med" len="med"/>
+                      <a:tailEnd type="none" w="med" len="med"/>
+                    </a:lnT>
+                    <a:lnB w="6350" cap="flat" cmpd="sng" algn="ctr">
+                      <a:solidFill>
+                        <a:srgbClr val="E7EEF2"/>
+                      </a:solidFill>
+                      <a:prstDash val="solid"/>
+                      <a:round/>
+                      <a:headEnd type="none" w="med" len="med"/>
+                      <a:tailEnd type="none" w="med" len="med"/>
+                    </a:lnB>
+                    <a:solidFill>
+                      <a:srgbClr val="EAF6FB"/>
+                    </a:solidFill>
+                  </a:tcPr>
+                </a:tc>
+                <a:tc>
+                  <a:txBody>
+                    <a:bodyPr/>
+                    <a:lstStyle/>
+                    <a:p>
+                      <a:pPr algn="l" indent="0" marL="0">
+                        <a:buNone/>
+                      </a:pPr>
+                      <a:r>
+                        <a:rPr lang="en-US" sz="1100" dirty="0">
+                          <a:solidFill>
+                            <a:srgbClr val="33415C"/>
+                          </a:solidFill>
+                          <a:latin typeface="Calibri" pitchFamily="34" charset="0"/>
+                          <a:ea typeface="Calibri" pitchFamily="34" charset="-122"/>
+                          <a:cs typeface="Calibri" pitchFamily="34" charset="-120"/>
+                        </a:rPr>
+                        <a:t>0 at κ = 8 → 1 at κ = 30 (MP DFPT)</a:t>
+                      </a:r>
+                    </a:p>
+                  </a:txBody>
+                  <a:tcPr marL="76200" marR="76200" marT="25400" marB="25400" anchor="ctr">
+                    <a:lnL w="6350" cap="flat" cmpd="sng" algn="ctr">
+                      <a:solidFill>
+                        <a:srgbClr val="E7EEF2"/>
+                      </a:solidFill>
+                      <a:prstDash val="solid"/>
+                      <a:round/>
+                      <a:headEnd type="none" w="med" len="med"/>
+                      <a:tailEnd type="none" w="med" len="med"/>
+                    </a:lnL>
+                    <a:lnR w="6350" cap="flat" cmpd="sng" algn="ctr">
+                      <a:solidFill>
+                        <a:srgbClr val="E7EEF2"/>
+                      </a:solidFill>
+                      <a:prstDash val="solid"/>
+                      <a:round/>
+                      <a:headEnd type="none" w="med" len="med"/>
+                      <a:tailEnd type="none" w="med" len="med"/>
+                    </a:lnR>
+                    <a:lnT w="6350" cap="flat" cmpd="sng" algn="ctr">
+                      <a:solidFill>
+                        <a:srgbClr val="E7EEF2"/>
+                      </a:solidFill>
+                      <a:prstDash val="solid"/>
+                      <a:round/>
+                      <a:headEnd type="none" w="med" len="med"/>
+                      <a:tailEnd type="none" w="med" len="med"/>
+                    </a:lnT>
+                    <a:lnB w="6350" cap="flat" cmpd="sng" algn="ctr">
+                      <a:solidFill>
+                        <a:srgbClr val="E7EEF2"/>
+                      </a:solidFill>
+                      <a:prstDash val="solid"/>
+                      <a:round/>
+                      <a:headEnd type="none" w="med" len="med"/>
+                      <a:tailEnd type="none" w="med" len="med"/>
+                    </a:lnB>
+                    <a:solidFill>
+                      <a:srgbClr val="EAF6FB"/>
+                    </a:solidFill>
+                  </a:tcPr>
+                </a:tc>
+              </a:tr>
+            </a:tbl>
+          </a:graphicData>
+        </a:graphic>
+      </p:graphicFrame>
+      <p:sp>
+        <p:nvSpPr>
+          <p:cNvPr id="6" name="Text 6"/>
+          <p:cNvSpPr txBox="1"/>
+          <p:nvPr/>
+        </p:nvSpPr>
+        <p:spPr>
+          <a:xfrm>
+            <a:off x="566928" y="5138928"/>
+            <a:ext cx="6720840" cy="457200"/>
+          </a:xfrm>
+          <a:prstGeom prst="rect">
+            <a:avLst/>
+          </a:prstGeom>
+          <a:noFill/>
+          <a:ln/>
+        </p:spPr>
+        <p:txBody>
+          <a:bodyPr wrap="square" lIns="0" tIns="0" rIns="0" bIns="0" rtlCol="0" anchor="t"/>
+          <a:lstStyle/>
+          <a:p>
+            <a:pPr algn="l" indent="0" marL="0">
+              <a:lnSpc>
+                <a:spcPts val="1300"/>
+              </a:lnSpc>
+              <a:buNone/>
+            </a:pPr>
+            <a:r>
+              <a:rPr lang="en-US" sz="950" dirty="0">
+                <a:solidFill>
+                  <a:srgbClr val="64748B"/>
+                </a:solidFill>
+                <a:latin typeface="Calibri" pitchFamily="34" charset="0"/>
+                <a:ea typeface="Calibri" pitchFamily="34" charset="-122"/>
+                <a:cs typeface="Calibri" pitchFamily="34" charset="-120"/>
+              </a:rPr>
+              <a:t>★ the figure of merit — thermal-barrier swaps it for Clarke κ</a:t>
+            </a:r>
+            <a:r>
+              <a:rPr lang="en-US" sz="950" baseline="-25000" dirty="0">
+                <a:solidFill>
+                  <a:srgbClr val="64748B"/>
+                </a:solidFill>
+                <a:latin typeface="Calibri" pitchFamily="34" charset="0"/>
+                <a:ea typeface="Calibri" pitchFamily="34" charset="-122"/>
+                <a:cs typeface="Calibri" pitchFamily="34" charset="-120"/>
+              </a:rPr>
+              <a:t>min</a:t>
+            </a:r>
+            <a:r>
+              <a:rPr lang="en-US" sz="950" dirty="0">
+                <a:solidFill>
+                  <a:srgbClr val="64748B"/>
+                </a:solidFill>
+                <a:latin typeface="Calibri" pitchFamily="34" charset="0"/>
+                <a:ea typeface="Calibri" pitchFamily="34" charset="-122"/>
+                <a:cs typeface="Calibri" pitchFamily="34" charset="-120"/>
+              </a:rPr>
+              <a:t>. Every weight halved or × 1.5 keeps the top tier in the top ten.</a:t>
+            </a:r>
+          </a:p>
+        </p:txBody>
+      </p:sp>
+      <p:sp>
+        <p:nvSpPr>
+          <p:cNvPr id="7" name="Shape 7"/>
+          <p:cNvSpPr/>
+          <p:nvPr/>
+        </p:nvSpPr>
+        <p:spPr>
+          <a:xfrm>
+            <a:off x="7607808" y="2148840"/>
+            <a:ext cx="4014216" cy="2606040"/>
+          </a:xfrm>
+          <a:prstGeom prst="roundRect">
+            <a:avLst>
+              <a:gd name="adj" fmla="val 7826"/>
+            </a:avLst>
+          </a:prstGeom>
+          <a:solidFill>
+            <a:srgbClr val="EAF3EC"/>
+          </a:solidFill>
+          <a:ln w="12700">
+            <a:solidFill>
+              <a:srgbClr val="C7DECC"/>
+            </a:solidFill>
+            <a:prstDash val="solid"/>
+          </a:ln>
+        </p:spPr>
+      </p:sp>
+      <p:sp>
+        <p:nvSpPr>
+          <p:cNvPr id="8" name="Text 8"/>
+          <p:cNvSpPr txBox="1"/>
+          <p:nvPr/>
+        </p:nvSpPr>
+        <p:spPr>
+          <a:xfrm>
+            <a:off x="7863840" y="2313432"/>
+            <a:ext cx="3474720" cy="219456"/>
+          </a:xfrm>
+          <a:prstGeom prst="rect">
+            <a:avLst/>
+          </a:prstGeom>
+          <a:noFill/>
+          <a:ln/>
+        </p:spPr>
+        <p:txBody>
+          <a:bodyPr wrap="square" lIns="0" tIns="0" rIns="0" bIns="0" rtlCol="0" anchor="ctr"/>
+          <a:lstStyle/>
+          <a:p>
+            <a:pPr algn="l" indent="0" marL="0">
+              <a:buNone/>
+            </a:pPr>
+            <a:r>
+              <a:rPr lang="en-US" sz="1000" b="1" dirty="0">
+                <a:solidFill>
+                  <a:srgbClr val="3A7D44"/>
+                </a:solidFill>
+                <a:latin typeface="Courier New" pitchFamily="34" charset="0"/>
+                <a:ea typeface="Courier New" pitchFamily="34" charset="-122"/>
+                <a:cs typeface="Courier New" pitchFamily="34" charset="-120"/>
+              </a:rPr>
+              <a:t>HARD GATES</a:t>
+            </a:r>
+          </a:p>
+        </p:txBody>
+      </p:sp>
+      <p:sp>
+        <p:nvSpPr>
+          <p:cNvPr id="9" name="Text 9"/>
+          <p:cNvSpPr txBox="1"/>
+          <p:nvPr/>
+        </p:nvSpPr>
+        <p:spPr>
+          <a:xfrm>
+            <a:off x="7863840" y="2624328"/>
+            <a:ext cx="3502152" cy="1554480"/>
+          </a:xfrm>
+          <a:prstGeom prst="rect">
+            <a:avLst/>
+          </a:prstGeom>
+          <a:noFill/>
+          <a:ln/>
+        </p:spPr>
+        <p:txBody>
+          <a:bodyPr wrap="square" lIns="0" tIns="0" rIns="0" bIns="0" rtlCol="0" anchor="t"/>
+          <a:lstStyle/>
+          <a:p>
+            <a:pPr algn="l" indent="0" marL="0">
+              <a:lnSpc>
+                <a:spcPts val="1500"/>
+              </a:lnSpc>
+              <a:spcAft>
+                <a:spcPts val="500"/>
+              </a:spcAft>
+              <a:buNone/>
+            </a:pPr>
+            <a:r>
+              <a:rPr lang="en-US" sz="1000" dirty="0">
+                <a:solidFill>
+                  <a:srgbClr val="2A6F97"/>
+                </a:solidFill>
+                <a:latin typeface="Courier New" pitchFamily="34" charset="0"/>
+                <a:ea typeface="Courier New" pitchFamily="34" charset="-122"/>
+                <a:cs typeface="Courier New" pitchFamily="34" charset="-120"/>
+              </a:rPr>
+              <a:t>▸  </a:t>
+            </a:r>
+            <a:r>
+              <a:rPr lang="en-US" sz="1100" b="1" dirty="0">
+                <a:solidFill>
+                  <a:srgbClr val="14213D"/>
+                </a:solidFill>
+                <a:latin typeface="Calibri" pitchFamily="34" charset="0"/>
+                <a:ea typeface="Calibri" pitchFamily="34" charset="-122"/>
+                <a:cs typeface="Calibri" pitchFamily="34" charset="-120"/>
+              </a:rPr>
+              <a:t>E</a:t>
+            </a:r>
+            <a:r>
+              <a:rPr lang="en-US" sz="1100" b="1" baseline="-25000" dirty="0">
+                <a:solidFill>
+                  <a:srgbClr val="14213D"/>
+                </a:solidFill>
+                <a:latin typeface="Calibri" pitchFamily="34" charset="0"/>
+                <a:ea typeface="Calibri" pitchFamily="34" charset="-122"/>
+                <a:cs typeface="Calibri" pitchFamily="34" charset="-120"/>
+              </a:rPr>
+              <a:t>hull</a:t>
+            </a:r>
+            <a:r>
+              <a:rPr lang="en-US" sz="1100" b="1" dirty="0">
+                <a:solidFill>
+                  <a:srgbClr val="14213D"/>
+                </a:solidFill>
+                <a:latin typeface="Calibri" pitchFamily="34" charset="0"/>
+                <a:ea typeface="Calibri" pitchFamily="34" charset="-122"/>
+                <a:cs typeface="Calibri" pitchFamily="34" charset="-120"/>
+              </a:rPr>
+              <a:t> ≤ 0.05 eV/atom</a:t>
+            </a:r>
+            <a:r>
+              <a:rPr lang="en-US" sz="1100" dirty="0">
+                <a:solidFill>
+                  <a:srgbClr val="33415C"/>
+                </a:solidFill>
+                <a:latin typeface="Calibri" pitchFamily="34" charset="0"/>
+                <a:ea typeface="Calibri" pitchFamily="34" charset="-122"/>
+                <a:cs typeface="Calibri" pitchFamily="34" charset="-120"/>
+              </a:rPr>
+              <a:t> — unknown → excluded</a:t>
+            </a:r>
+          </a:p>
+          <a:p>
+            <a:pPr algn="l" indent="0" marL="0">
+              <a:lnSpc>
+                <a:spcPts val="1500"/>
+              </a:lnSpc>
+              <a:spcAft>
+                <a:spcPts val="500"/>
+              </a:spcAft>
+              <a:buNone/>
+            </a:pPr>
+            <a:r>
+              <a:rPr lang="en-US" sz="1000" dirty="0">
+                <a:solidFill>
+                  <a:srgbClr val="2A6F97"/>
+                </a:solidFill>
+                <a:latin typeface="Courier New" pitchFamily="34" charset="0"/>
+                <a:ea typeface="Courier New" pitchFamily="34" charset="-122"/>
+                <a:cs typeface="Courier New" pitchFamily="34" charset="-120"/>
+              </a:rPr>
+              <a:t>▸  </a:t>
+            </a:r>
+            <a:r>
+              <a:rPr lang="en-US" sz="1100" b="1" dirty="0">
+                <a:solidFill>
+                  <a:srgbClr val="14213D"/>
+                </a:solidFill>
+                <a:latin typeface="Calibri" pitchFamily="34" charset="0"/>
+                <a:ea typeface="Calibri" pitchFamily="34" charset="-122"/>
+                <a:cs typeface="Calibri" pitchFamily="34" charset="-120"/>
+              </a:rPr>
+              <a:t>effective band gap ≥ 4.0 eV</a:t>
+            </a:r>
+            <a:r>
+              <a:rPr lang="en-US" sz="1100" dirty="0">
+                <a:solidFill>
+                  <a:srgbClr val="33415C"/>
+                </a:solidFill>
+                <a:latin typeface="Calibri" pitchFamily="34" charset="0"/>
+                <a:ea typeface="Calibri" pitchFamily="34" charset="-122"/>
+                <a:cs typeface="Calibri" pitchFamily="34" charset="-120"/>
+              </a:rPr>
+              <a:t> — unknown → excluded</a:t>
+            </a:r>
+          </a:p>
+          <a:p>
+            <a:pPr algn="l" indent="0" marL="0">
+              <a:lnSpc>
+                <a:spcPts val="1500"/>
+              </a:lnSpc>
+              <a:spcAft>
+                <a:spcPts val="500"/>
+              </a:spcAft>
+              <a:buNone/>
+            </a:pPr>
+            <a:r>
+              <a:rPr lang="en-US" sz="1000" dirty="0">
+                <a:solidFill>
+                  <a:srgbClr val="2A6F97"/>
+                </a:solidFill>
+                <a:latin typeface="Courier New" pitchFamily="34" charset="0"/>
+                <a:ea typeface="Courier New" pitchFamily="34" charset="-122"/>
+                <a:cs typeface="Courier New" pitchFamily="34" charset="-120"/>
+              </a:rPr>
+              <a:t>▸  </a:t>
+            </a:r>
+            <a:r>
+              <a:rPr lang="en-US" sz="1100" b="1" dirty="0">
+                <a:solidFill>
+                  <a:srgbClr val="14213D"/>
+                </a:solidFill>
+                <a:latin typeface="Calibri" pitchFamily="34" charset="0"/>
+                <a:ea typeface="Calibri" pitchFamily="34" charset="-122"/>
+                <a:cs typeface="Calibri" pitchFamily="34" charset="-120"/>
+              </a:rPr>
+              <a:t>≤ 3 distinct elements</a:t>
+            </a:r>
+            <a:r>
+              <a:rPr lang="en-US" sz="1100" dirty="0">
+                <a:solidFill>
+                  <a:srgbClr val="33415C"/>
+                </a:solidFill>
+                <a:latin typeface="Calibri" pitchFamily="34" charset="0"/>
+                <a:ea typeface="Calibri" pitchFamily="34" charset="-122"/>
+                <a:cs typeface="Calibri" pitchFamily="34" charset="-120"/>
+              </a:rPr>
+              <a:t/>
+            </a:r>
+          </a:p>
+          <a:p>
+            <a:pPr algn="l" indent="0" marL="0">
+              <a:lnSpc>
+                <a:spcPts val="1500"/>
+              </a:lnSpc>
+              <a:spcAft>
+                <a:spcPts val="500"/>
+              </a:spcAft>
+              <a:buNone/>
+            </a:pPr>
+            <a:r>
+              <a:rPr lang="en-US" sz="1000" dirty="0">
+                <a:solidFill>
+                  <a:srgbClr val="2A6F97"/>
+                </a:solidFill>
+                <a:latin typeface="Courier New" pitchFamily="34" charset="0"/>
+                <a:ea typeface="Courier New" pitchFamily="34" charset="-122"/>
+                <a:cs typeface="Courier New" pitchFamily="34" charset="-120"/>
+              </a:rPr>
+              <a:t>▸  </a:t>
+            </a:r>
+            <a:r>
+              <a:rPr lang="en-US" sz="1100" b="1" dirty="0">
+                <a:solidFill>
+                  <a:srgbClr val="14213D"/>
+                </a:solidFill>
+                <a:latin typeface="Calibri" pitchFamily="34" charset="0"/>
+                <a:ea typeface="Calibri" pitchFamily="34" charset="-122"/>
+                <a:cs typeface="Calibri" pitchFamily="34" charset="-120"/>
+              </a:rPr>
+              <a:t>no tier-2 element</a:t>
+            </a:r>
+            <a:r>
+              <a:rPr lang="en-US" sz="1100" dirty="0">
+                <a:solidFill>
+                  <a:srgbClr val="33415C"/>
+                </a:solidFill>
+                <a:latin typeface="Calibri" pitchFamily="34" charset="0"/>
+                <a:ea typeface="Calibri" pitchFamily="34" charset="-122"/>
+                <a:cs typeface="Calibri" pitchFamily="34" charset="-120"/>
+              </a:rPr>
+              <a:t> (Pb, Cd, Hg, As, Tl, Be …) — no request can lift this</a:t>
+            </a:r>
+          </a:p>
+        </p:txBody>
+      </p:sp>
+      <p:sp>
+        <p:nvSpPr>
+          <p:cNvPr id="10" name="Text 10"/>
+          <p:cNvSpPr txBox="1"/>
+          <p:nvPr/>
+        </p:nvSpPr>
+        <p:spPr>
+          <a:xfrm>
+            <a:off x="7863840" y="4206240"/>
+            <a:ext cx="3502152" cy="411480"/>
+          </a:xfrm>
+          <a:prstGeom prst="rect">
+            <a:avLst/>
+          </a:prstGeom>
+          <a:noFill/>
+          <a:ln/>
+        </p:spPr>
+        <p:txBody>
+          <a:bodyPr wrap="square" lIns="0" tIns="0" rIns="0" bIns="0" rtlCol="0" anchor="t"/>
+          <a:lstStyle/>
+          <a:p>
+            <a:pPr algn="l" indent="0" marL="0">
+              <a:lnSpc>
+                <a:spcPts val="1250"/>
+              </a:lnSpc>
+              <a:buNone/>
+            </a:pPr>
+            <a:r>
+              <a:rPr lang="en-US" sz="950" dirty="0">
+                <a:solidFill>
+                  <a:srgbClr val="64748B"/>
+                </a:solidFill>
+                <a:latin typeface="Calibri" pitchFamily="34" charset="0"/>
+                <a:ea typeface="Calibri" pitchFamily="34" charset="-122"/>
+                <a:cs typeface="Calibri" pitchFamily="34" charset="-120"/>
+              </a:rPr>
+              <a:t>Plus required / excluded elements from the request. A missing κ is caveated, not excluded.</a:t>
+            </a:r>
+          </a:p>
+        </p:txBody>
+      </p:sp>
+      <p:sp>
+        <p:nvSpPr>
+          <p:cNvPr id="11" name="Shape 11"/>
+          <p:cNvSpPr/>
+          <p:nvPr/>
+        </p:nvSpPr>
+        <p:spPr>
+          <a:xfrm>
+            <a:off x="7607808" y="4919472"/>
+            <a:ext cx="4014216" cy="1325880"/>
+          </a:xfrm>
+          <a:prstGeom prst="roundRect">
+            <a:avLst>
+              <a:gd name="adj" fmla="val 7826"/>
+            </a:avLst>
+          </a:prstGeom>
+          <a:solidFill>
+            <a:srgbClr val="FFFFFF"/>
+          </a:solidFill>
+          <a:ln w="12700">
+            <a:solidFill>
+              <a:srgbClr val="D8E2E9"/>
+            </a:solidFill>
+            <a:prstDash val="solid"/>
+          </a:ln>
+        </p:spPr>
+      </p:sp>
+      <p:sp>
+        <p:nvSpPr>
+          <p:cNvPr id="12" name="Text 12"/>
+          <p:cNvSpPr txBox="1"/>
+          <p:nvPr/>
+        </p:nvSpPr>
+        <p:spPr>
+          <a:xfrm>
+            <a:off x="7863840" y="5065776"/>
+            <a:ext cx="3474720" cy="219456"/>
+          </a:xfrm>
+          <a:prstGeom prst="rect">
+            <a:avLst/>
+          </a:prstGeom>
+          <a:noFill/>
+          <a:ln/>
+        </p:spPr>
+        <p:txBody>
+          <a:bodyPr wrap="square" lIns="0" tIns="0" rIns="0" bIns="0" rtlCol="0" anchor="ctr"/>
+          <a:lstStyle/>
+          <a:p>
+            <a:pPr algn="l" indent="0" marL="0">
+              <a:buNone/>
+            </a:pPr>
+            <a:r>
+              <a:rPr lang="en-US" sz="1000" b="1" dirty="0">
+                <a:solidFill>
+                  <a:srgbClr val="64748B"/>
+                </a:solidFill>
+                <a:latin typeface="Courier New" pitchFamily="34" charset="0"/>
+                <a:ea typeface="Courier New" pitchFamily="34" charset="-122"/>
+                <a:cs typeface="Courier New" pitchFamily="34" charset="-120"/>
+              </a:rPr>
+              <a:t>GATE ≠ CRITERION</a:t>
+            </a:r>
+          </a:p>
+        </p:txBody>
+      </p:sp>
+      <p:sp>
+        <p:nvSpPr>
+          <p:cNvPr id="13" name="Text 13"/>
+          <p:cNvSpPr txBox="1"/>
+          <p:nvPr/>
+        </p:nvSpPr>
+        <p:spPr>
+          <a:xfrm>
+            <a:off x="7863840" y="5358384"/>
+            <a:ext cx="3502152" cy="777240"/>
+          </a:xfrm>
+          <a:prstGeom prst="rect">
+            <a:avLst/>
+          </a:prstGeom>
+          <a:noFill/>
+          <a:ln/>
+        </p:spPr>
+        <p:txBody>
+          <a:bodyPr wrap="square" lIns="0" tIns="0" rIns="0" bIns="0" rtlCol="0" anchor="t"/>
+          <a:lstStyle/>
+          <a:p>
+            <a:pPr algn="l" indent="0" marL="0">
+              <a:lnSpc>
+                <a:spcPts val="1500"/>
+              </a:lnSpc>
+              <a:buNone/>
+            </a:pPr>
+            <a:r>
+              <a:rPr lang="en-US" sz="1100" dirty="0">
+                <a:solidFill>
+                  <a:srgbClr val="33415C"/>
+                </a:solidFill>
+                <a:latin typeface="Calibri" pitchFamily="34" charset="0"/>
+                <a:ea typeface="Calibri" pitchFamily="34" charset="-122"/>
+                <a:cs typeface="Calibri" pitchFamily="34" charset="-120"/>
+              </a:rPr>
+              <a:t>Interface and literature only score. Ta₂O₅ passes every gate and ranks 99th with a caveat naming the reaction, rather than vanishing.</a:t>
+            </a:r>
+          </a:p>
+        </p:txBody>
+      </p:sp>
+    </p:spTree>
+  </p:cSld>
+  <p:clrMapOvr>
+    <a:masterClrMapping/>
+  </p:clrMapOvr>
+</p:sld>
+</file>
+
 <file path=ppt/slides/slide2.xml><?xml version="1.0" encoding="utf-8"?>
 <p:sld xmlns:a="http://schemas.openxmlformats.org/drawingml/2006/main" xmlns:r="http://schemas.openxmlformats.org/officeDocument/2006/relationships" xmlns:p="http://schemas.openxmlformats.org/presentationml/2006/main">
   <p:cSld name="Slide 2">

</xml_diff>